<commit_message>
Edit to the slides
</commit_message>
<xml_diff>
--- a/slides/Intel_CET_Linux_Summit_NA_2026.pptx
+++ b/slides/Intel_CET_Linux_Summit_NA_2026.pptx
@@ -225,7 +225,7 @@
           <a:p>
             <a:fld id="{F49FE757-DDF4-A24B-877B-B462EA62A178}" type="datetimeFigureOut">
               <a:rPr lang="en-US" smtClean="0"/>
-              <a:t>5/19/26</a:t>
+              <a:t>5/20/26</a:t>
             </a:fld>
             <a:endParaRPr lang="en-US"/>
           </a:p>
@@ -1674,7 +1674,7 @@
           <a:p>
             <a:fld id="{5BCAD085-E8A6-8845-BD4E-CB4CCA059FC4}" type="datetimeFigureOut">
               <a:rPr lang="en-US" smtClean="0"/>
-              <a:t>5/19/26</a:t>
+              <a:t>5/20/26</a:t>
             </a:fld>
             <a:endParaRPr lang="en-US"/>
           </a:p>
@@ -1842,7 +1842,7 @@
           <a:p>
             <a:fld id="{5BCAD085-E8A6-8845-BD4E-CB4CCA059FC4}" type="datetimeFigureOut">
               <a:rPr lang="en-US" smtClean="0"/>
-              <a:t>5/19/26</a:t>
+              <a:t>5/20/26</a:t>
             </a:fld>
             <a:endParaRPr lang="en-US"/>
           </a:p>
@@ -2020,7 +2020,7 @@
           <a:p>
             <a:fld id="{5BCAD085-E8A6-8845-BD4E-CB4CCA059FC4}" type="datetimeFigureOut">
               <a:rPr lang="en-US" smtClean="0"/>
-              <a:t>5/19/26</a:t>
+              <a:t>5/20/26</a:t>
             </a:fld>
             <a:endParaRPr lang="en-US"/>
           </a:p>
@@ -2188,7 +2188,7 @@
           <a:p>
             <a:fld id="{5BCAD085-E8A6-8845-BD4E-CB4CCA059FC4}" type="datetimeFigureOut">
               <a:rPr lang="en-US" smtClean="0"/>
-              <a:t>5/19/26</a:t>
+              <a:t>5/20/26</a:t>
             </a:fld>
             <a:endParaRPr lang="en-US"/>
           </a:p>
@@ -2433,7 +2433,7 @@
           <a:p>
             <a:fld id="{5BCAD085-E8A6-8845-BD4E-CB4CCA059FC4}" type="datetimeFigureOut">
               <a:rPr lang="en-US" smtClean="0"/>
-              <a:t>5/19/26</a:t>
+              <a:t>5/20/26</a:t>
             </a:fld>
             <a:endParaRPr lang="en-US"/>
           </a:p>
@@ -2718,7 +2718,7 @@
           <a:p>
             <a:fld id="{5BCAD085-E8A6-8845-BD4E-CB4CCA059FC4}" type="datetimeFigureOut">
               <a:rPr lang="en-US" smtClean="0"/>
-              <a:t>5/19/26</a:t>
+              <a:t>5/20/26</a:t>
             </a:fld>
             <a:endParaRPr lang="en-US"/>
           </a:p>
@@ -3137,7 +3137,7 @@
           <a:p>
             <a:fld id="{5BCAD085-E8A6-8845-BD4E-CB4CCA059FC4}" type="datetimeFigureOut">
               <a:rPr lang="en-US" smtClean="0"/>
-              <a:t>5/19/26</a:t>
+              <a:t>5/20/26</a:t>
             </a:fld>
             <a:endParaRPr lang="en-US"/>
           </a:p>
@@ -3254,7 +3254,7 @@
           <a:p>
             <a:fld id="{5BCAD085-E8A6-8845-BD4E-CB4CCA059FC4}" type="datetimeFigureOut">
               <a:rPr lang="en-US" smtClean="0"/>
-              <a:t>5/19/26</a:t>
+              <a:t>5/20/26</a:t>
             </a:fld>
             <a:endParaRPr lang="en-US"/>
           </a:p>
@@ -3349,7 +3349,7 @@
           <a:p>
             <a:fld id="{5BCAD085-E8A6-8845-BD4E-CB4CCA059FC4}" type="datetimeFigureOut">
               <a:rPr lang="en-US" smtClean="0"/>
-              <a:t>5/19/26</a:t>
+              <a:t>5/20/26</a:t>
             </a:fld>
             <a:endParaRPr lang="en-US"/>
           </a:p>
@@ -3624,7 +3624,7 @@
           <a:p>
             <a:fld id="{5BCAD085-E8A6-8845-BD4E-CB4CCA059FC4}" type="datetimeFigureOut">
               <a:rPr lang="en-US" smtClean="0"/>
-              <a:t>5/19/26</a:t>
+              <a:t>5/20/26</a:t>
             </a:fld>
             <a:endParaRPr lang="en-US"/>
           </a:p>
@@ -3876,7 +3876,7 @@
           <a:p>
             <a:fld id="{5BCAD085-E8A6-8845-BD4E-CB4CCA059FC4}" type="datetimeFigureOut">
               <a:rPr lang="en-US" smtClean="0"/>
-              <a:t>5/19/26</a:t>
+              <a:t>5/20/26</a:t>
             </a:fld>
             <a:endParaRPr lang="en-US"/>
           </a:p>
@@ -4087,7 +4087,7 @@
           <a:p>
             <a:fld id="{5BCAD085-E8A6-8845-BD4E-CB4CCA059FC4}" type="datetimeFigureOut">
               <a:rPr lang="en-US" smtClean="0"/>
-              <a:t>5/19/26</a:t>
+              <a:t>5/20/26</a:t>
             </a:fld>
             <a:endParaRPr lang="en-US"/>
           </a:p>
@@ -4638,7 +4638,7 @@
         </p:nvGrpSpPr>
         <p:grpSpPr>
           <a:xfrm>
-            <a:off x="588757" y="4594860"/>
+            <a:off x="447675" y="4606436"/>
             <a:ext cx="2573991" cy="533400"/>
             <a:chOff x="438150" y="4581525"/>
             <a:chExt cx="2573991" cy="533400"/>
@@ -4744,13 +4744,13 @@
   <p:clrMapOvr>
     <a:masterClrMapping/>
   </p:clrMapOvr>
-  <mc:AlternateContent xmlns:mc="http://schemas.openxmlformats.org/markup-compatibility/2006">
-    <mc:Choice xmlns:p14="http://schemas.microsoft.com/office/powerpoint/2010/main" Requires="p14">
+  <mc:AlternateContent xmlns:mc="http://schemas.openxmlformats.org/markup-compatibility/2006" xmlns:p14="http://schemas.microsoft.com/office/powerpoint/2010/main">
+    <mc:Choice Requires="p14">
       <p:transition p14:dur="400">
         <p:fade/>
       </p:transition>
     </mc:Choice>
-    <mc:Fallback>
+    <mc:Fallback xmlns="">
       <p:transition>
         <p:fade/>
       </p:transition>
@@ -7682,13 +7682,13 @@
   <p:clrMapOvr>
     <a:masterClrMapping/>
   </p:clrMapOvr>
-  <mc:AlternateContent xmlns:mc="http://schemas.openxmlformats.org/markup-compatibility/2006">
-    <mc:Choice xmlns:p14="http://schemas.microsoft.com/office/powerpoint/2010/main" Requires="p14">
+  <mc:AlternateContent xmlns:mc="http://schemas.openxmlformats.org/markup-compatibility/2006" xmlns:p14="http://schemas.microsoft.com/office/powerpoint/2010/main">
+    <mc:Choice Requires="p14">
       <p:transition p14:dur="400">
         <p:fade/>
       </p:transition>
     </mc:Choice>
-    <mc:Fallback>
+    <mc:Fallback xmlns="">
       <p:transition>
         <p:fade/>
       </p:transition>
@@ -10269,13 +10269,13 @@
   <p:clrMapOvr>
     <a:masterClrMapping/>
   </p:clrMapOvr>
-  <mc:AlternateContent xmlns:mc="http://schemas.openxmlformats.org/markup-compatibility/2006">
-    <mc:Choice xmlns:p14="http://schemas.microsoft.com/office/powerpoint/2010/main" Requires="p14">
+  <mc:AlternateContent xmlns:mc="http://schemas.openxmlformats.org/markup-compatibility/2006" xmlns:p14="http://schemas.microsoft.com/office/powerpoint/2010/main">
+    <mc:Choice Requires="p14">
       <p:transition p14:dur="400">
         <p:fade/>
       </p:transition>
     </mc:Choice>
-    <mc:Fallback>
+    <mc:Fallback xmlns="">
       <p:transition>
         <p:fade/>
       </p:transition>
@@ -12169,97 +12169,13 @@
         </p:sp>
         <p:sp>
           <p:nvSpPr>
-            <p:cNvPr id="47" name="TextBox 47"/>
-            <p:cNvSpPr txBox="1"/>
-            <p:nvPr/>
-          </p:nvSpPr>
-          <p:spPr>
-            <a:xfrm>
-              <a:off x="3806071" y="5307806"/>
-              <a:ext cx="4579858" cy="228600"/>
-            </a:xfrm>
-            <a:prstGeom prst="rect">
-              <a:avLst/>
-            </a:prstGeom>
-            <a:noFill/>
-            <a:ln>
-              <a:noFill/>
-            </a:ln>
-          </p:spPr>
-          <p:txBody>
-            <a:bodyPr wrap="none" lIns="0" tIns="0" rIns="0" bIns="0" anchor="t" anchorCtr="0">
-              <a:spAutoFit/>
-            </a:bodyPr>
-            <a:lstStyle/>
-            <a:p>
-              <a:pPr algn="ctr"/>
-              <a:r>
-                <a:rPr lang="zh-CN" sz="1125" b="1" dirty="0">
-                  <a:solidFill>
-                    <a:srgbClr val="0AB36E"/>
-                  </a:solidFill>
-                  <a:latin typeface="Arial"/>
-                  <a:ea typeface="Microsoft YaHei"/>
-                  <a:cs typeface="Arial"/>
-                </a:rPr>
-                <a:t>sa_restorer</a:t>
-              </a:r>
-              <a:r>
-                <a:rPr lang="zh-CN" sz="1125" dirty="0">
-                  <a:solidFill>
-                    <a:srgbClr val="FFFFFF"/>
-                  </a:solidFill>
-                  <a:latin typeface="Arial"/>
-                  <a:ea typeface="Microsoft YaHei"/>
-                  <a:cs typeface="Arial"/>
-                </a:rPr>
-                <a:t> = </a:t>
-              </a:r>
-              <a:r>
-                <a:rPr lang="zh-CN" sz="1125" dirty="0">
-                  <a:solidFill>
-                    <a:srgbClr val="F79646"/>
-                  </a:solidFill>
-                  <a:latin typeface="Consolas"/>
-                  <a:ea typeface="Microsoft YaHei"/>
-                  <a:cs typeface="Consolas"/>
-                </a:rPr>
-                <a:t>__restore_rt</a:t>
-              </a:r>
-              <a:r>
-                <a:rPr lang="zh-CN" sz="1125" dirty="0">
-                  <a:solidFill>
-                    <a:srgbClr val="FFFFFF"/>
-                  </a:solidFill>
-                  <a:latin typeface="Arial"/>
-                  <a:ea typeface="Microsoft YaHei"/>
-                  <a:cs typeface="Arial"/>
-                </a:rPr>
-                <a:t> in vDSO — calls </a:t>
-              </a:r>
-              <a:r>
-                <a:rPr lang="zh-CN" sz="1125" dirty="0">
-                  <a:solidFill>
-                    <a:srgbClr val="F79646"/>
-                  </a:solidFill>
-                  <a:latin typeface="Consolas"/>
-                  <a:ea typeface="Microsoft YaHei"/>
-                  <a:cs typeface="Consolas"/>
-                </a:rPr>
-                <a:t>rt_sigreturn</a:t>
-              </a:r>
-            </a:p>
-          </p:txBody>
-        </p:sp>
-        <p:sp>
-          <p:nvSpPr>
             <p:cNvPr id="48" name="TextBox 48"/>
             <p:cNvSpPr txBox="1"/>
             <p:nvPr/>
           </p:nvSpPr>
           <p:spPr>
             <a:xfrm>
-              <a:off x="3484840" y="5533549"/>
+              <a:off x="3484840" y="5349239"/>
               <a:ext cx="5222319" cy="198120"/>
             </a:xfrm>
             <a:prstGeom prst="rect">
@@ -12380,13 +12296,13 @@
   <p:clrMapOvr>
     <a:masterClrMapping/>
   </p:clrMapOvr>
-  <mc:AlternateContent xmlns:mc="http://schemas.openxmlformats.org/markup-compatibility/2006">
-    <mc:Choice xmlns:p14="http://schemas.microsoft.com/office/powerpoint/2010/main" Requires="p14">
+  <mc:AlternateContent xmlns:mc="http://schemas.openxmlformats.org/markup-compatibility/2006" xmlns:p14="http://schemas.microsoft.com/office/powerpoint/2010/main">
+    <mc:Choice Requires="p14">
       <p:transition p14:dur="400">
         <p:fade/>
       </p:transition>
     </mc:Choice>
-    <mc:Fallback>
+    <mc:Fallback xmlns="">
       <p:transition>
         <p:fade/>
       </p:transition>
@@ -14128,7 +14044,7 @@
           <p:spPr>
             <a:xfrm>
               <a:off x="7607618" y="2523649"/>
-              <a:ext cx="1633871" cy="198120"/>
+              <a:ext cx="965008" cy="150041"/>
             </a:xfrm>
             <a:prstGeom prst="rect">
               <a:avLst/>
@@ -14154,7 +14070,7 @@
                   <a:ea typeface="Microsoft YaHei"/>
                   <a:cs typeface="Consolas"/>
                 </a:rPr>
-                <a:t>= __restore_rt in vDSO</a:t>
+                <a:t>= __restore_rt</a:t>
               </a:r>
             </a:p>
           </p:txBody>
@@ -14734,13 +14650,13 @@
   <p:clrMapOvr>
     <a:masterClrMapping/>
   </p:clrMapOvr>
-  <mc:AlternateContent xmlns:mc="http://schemas.openxmlformats.org/markup-compatibility/2006">
-    <mc:Choice xmlns:p14="http://schemas.microsoft.com/office/powerpoint/2010/main" Requires="p14">
+  <mc:AlternateContent xmlns:mc="http://schemas.openxmlformats.org/markup-compatibility/2006" xmlns:p14="http://schemas.microsoft.com/office/powerpoint/2010/main">
+    <mc:Choice Requires="p14">
       <p:transition p14:dur="400">
         <p:fade/>
       </p:transition>
     </mc:Choice>
-    <mc:Fallback>
+    <mc:Fallback xmlns="">
       <p:transition>
         <p:fade/>
       </p:transition>
@@ -17695,13 +17611,13 @@
   <p:clrMapOvr>
     <a:masterClrMapping/>
   </p:clrMapOvr>
-  <mc:AlternateContent xmlns:mc="http://schemas.openxmlformats.org/markup-compatibility/2006">
-    <mc:Choice xmlns:p14="http://schemas.microsoft.com/office/powerpoint/2010/main" Requires="p14">
+  <mc:AlternateContent xmlns:mc="http://schemas.openxmlformats.org/markup-compatibility/2006" xmlns:p14="http://schemas.microsoft.com/office/powerpoint/2010/main">
+    <mc:Choice Requires="p14">
       <p:transition p14:dur="400">
         <p:fade/>
       </p:transition>
     </mc:Choice>
-    <mc:Fallback>
+    <mc:Fallback xmlns="">
       <p:transition>
         <p:fade/>
       </p:transition>
@@ -20173,13 +20089,13 @@
   <p:clrMapOvr>
     <a:masterClrMapping/>
   </p:clrMapOvr>
-  <mc:AlternateContent xmlns:mc="http://schemas.openxmlformats.org/markup-compatibility/2006">
-    <mc:Choice xmlns:p14="http://schemas.microsoft.com/office/powerpoint/2010/main" Requires="p14">
+  <mc:AlternateContent xmlns:mc="http://schemas.openxmlformats.org/markup-compatibility/2006" xmlns:p14="http://schemas.microsoft.com/office/powerpoint/2010/main">
+    <mc:Choice Requires="p14">
       <p:transition p14:dur="400">
         <p:fade/>
       </p:transition>
     </mc:Choice>
-    <mc:Fallback>
+    <mc:Fallback xmlns="">
       <p:transition>
         <p:fade/>
       </p:transition>
@@ -21424,10 +21340,10 @@
         </p:nvGrpSpPr>
         <p:grpSpPr>
           <a:xfrm>
-            <a:off x="476250" y="3314700"/>
-            <a:ext cx="5238750" cy="1585912"/>
-            <a:chOff x="476250" y="3314700"/>
-            <a:chExt cx="5238750" cy="1585912"/>
+            <a:off x="476250" y="3314699"/>
+            <a:ext cx="5238750" cy="1629251"/>
+            <a:chOff x="476250" y="3314699"/>
+            <a:chExt cx="5238750" cy="1629251"/>
           </a:xfrm>
         </p:grpSpPr>
         <p:sp>
@@ -21438,8 +21354,8 @@
           </p:nvSpPr>
           <p:spPr>
             <a:xfrm>
-              <a:off x="476250" y="3314700"/>
-              <a:ext cx="5238750" cy="1238250"/>
+              <a:off x="476250" y="3314699"/>
+              <a:ext cx="5238750" cy="1629251"/>
             </a:xfrm>
             <a:prstGeom prst="roundRect">
               <a:avLst>
@@ -22679,7 +22595,7 @@
         </p:nvGrpSpPr>
         <p:grpSpPr>
           <a:xfrm>
-            <a:off x="476250" y="4762500"/>
+            <a:off x="429696" y="5024437"/>
             <a:ext cx="11239500" cy="1000125"/>
             <a:chOff x="476250" y="4762500"/>
             <a:chExt cx="11239500" cy="1000125"/>
@@ -22944,13 +22860,13 @@
   <p:clrMapOvr>
     <a:masterClrMapping/>
   </p:clrMapOvr>
-  <mc:AlternateContent xmlns:mc="http://schemas.openxmlformats.org/markup-compatibility/2006">
-    <mc:Choice xmlns:p14="http://schemas.microsoft.com/office/powerpoint/2010/main" Requires="p14">
+  <mc:AlternateContent xmlns:mc="http://schemas.openxmlformats.org/markup-compatibility/2006" xmlns:p14="http://schemas.microsoft.com/office/powerpoint/2010/main">
+    <mc:Choice Requires="p14">
       <p:transition p14:dur="400">
         <p:fade/>
       </p:transition>
     </mc:Choice>
-    <mc:Fallback>
+    <mc:Fallback xmlns="">
       <p:transition>
         <p:fade/>
       </p:transition>
@@ -25263,13 +25179,13 @@
   <p:clrMapOvr>
     <a:masterClrMapping/>
   </p:clrMapOvr>
-  <mc:AlternateContent xmlns:mc="http://schemas.openxmlformats.org/markup-compatibility/2006">
-    <mc:Choice xmlns:p14="http://schemas.microsoft.com/office/powerpoint/2010/main" Requires="p14">
+  <mc:AlternateContent xmlns:mc="http://schemas.openxmlformats.org/markup-compatibility/2006" xmlns:p14="http://schemas.microsoft.com/office/powerpoint/2010/main">
+    <mc:Choice Requires="p14">
       <p:transition p14:dur="400">
         <p:fade/>
       </p:transition>
     </mc:Choice>
-    <mc:Fallback>
+    <mc:Fallback xmlns="">
       <p:transition>
         <p:fade/>
       </p:transition>
@@ -27037,13 +26953,13 @@
   <p:clrMapOvr>
     <a:masterClrMapping/>
   </p:clrMapOvr>
-  <mc:AlternateContent xmlns:mc="http://schemas.openxmlformats.org/markup-compatibility/2006">
-    <mc:Choice xmlns:p14="http://schemas.microsoft.com/office/powerpoint/2010/main" Requires="p14">
+  <mc:AlternateContent xmlns:mc="http://schemas.openxmlformats.org/markup-compatibility/2006" xmlns:p14="http://schemas.microsoft.com/office/powerpoint/2010/main">
+    <mc:Choice Requires="p14">
       <p:transition p14:dur="400">
         <p:fade/>
       </p:transition>
     </mc:Choice>
-    <mc:Fallback>
+    <mc:Fallback xmlns="">
       <p:transition>
         <p:fade/>
       </p:transition>
@@ -28416,13 +28332,13 @@
   <p:clrMapOvr>
     <a:masterClrMapping/>
   </p:clrMapOvr>
-  <mc:AlternateContent xmlns:mc="http://schemas.openxmlformats.org/markup-compatibility/2006">
-    <mc:Choice xmlns:p14="http://schemas.microsoft.com/office/powerpoint/2010/main" Requires="p14">
+  <mc:AlternateContent xmlns:mc="http://schemas.openxmlformats.org/markup-compatibility/2006" xmlns:p14="http://schemas.microsoft.com/office/powerpoint/2010/main">
+    <mc:Choice Requires="p14">
       <p:transition p14:dur="400">
         <p:fade/>
       </p:transition>
     </mc:Choice>
-    <mc:Fallback>
+    <mc:Fallback xmlns="">
       <p:transition>
         <p:fade/>
       </p:transition>
@@ -30245,13 +30161,13 @@
   <p:clrMapOvr>
     <a:masterClrMapping/>
   </p:clrMapOvr>
-  <mc:AlternateContent xmlns:mc="http://schemas.openxmlformats.org/markup-compatibility/2006">
-    <mc:Choice xmlns:p14="http://schemas.microsoft.com/office/powerpoint/2010/main" Requires="p14">
+  <mc:AlternateContent xmlns:mc="http://schemas.openxmlformats.org/markup-compatibility/2006" xmlns:p14="http://schemas.microsoft.com/office/powerpoint/2010/main">
+    <mc:Choice Requires="p14">
       <p:transition p14:dur="400">
         <p:fade/>
       </p:transition>
     </mc:Choice>
-    <mc:Fallback>
+    <mc:Fallback xmlns="">
       <p:transition>
         <p:fade/>
       </p:transition>
@@ -32445,13 +32361,13 @@
   <p:clrMapOvr>
     <a:masterClrMapping/>
   </p:clrMapOvr>
-  <mc:AlternateContent xmlns:mc="http://schemas.openxmlformats.org/markup-compatibility/2006">
-    <mc:Choice xmlns:p14="http://schemas.microsoft.com/office/powerpoint/2010/main" Requires="p14">
+  <mc:AlternateContent xmlns:mc="http://schemas.openxmlformats.org/markup-compatibility/2006" xmlns:p14="http://schemas.microsoft.com/office/powerpoint/2010/main">
+    <mc:Choice Requires="p14">
       <p:transition p14:dur="400">
         <p:fade/>
       </p:transition>
     </mc:Choice>
-    <mc:Fallback>
+    <mc:Fallback xmlns="">
       <p:transition>
         <p:fade/>
       </p:transition>
@@ -34543,13 +34459,13 @@
   <p:clrMapOvr>
     <a:masterClrMapping/>
   </p:clrMapOvr>
-  <mc:AlternateContent xmlns:mc="http://schemas.openxmlformats.org/markup-compatibility/2006">
-    <mc:Choice xmlns:p14="http://schemas.microsoft.com/office/powerpoint/2010/main" Requires="p14">
+  <mc:AlternateContent xmlns:mc="http://schemas.openxmlformats.org/markup-compatibility/2006" xmlns:p14="http://schemas.microsoft.com/office/powerpoint/2010/main">
+    <mc:Choice Requires="p14">
       <p:transition p14:dur="400">
         <p:fade/>
       </p:transition>
     </mc:Choice>
-    <mc:Fallback>
+    <mc:Fallback xmlns="">
       <p:transition>
         <p:fade/>
       </p:transition>
@@ -37109,13 +37025,13 @@
   <p:clrMapOvr>
     <a:masterClrMapping/>
   </p:clrMapOvr>
-  <mc:AlternateContent xmlns:mc="http://schemas.openxmlformats.org/markup-compatibility/2006">
-    <mc:Choice xmlns:p14="http://schemas.microsoft.com/office/powerpoint/2010/main" Requires="p14">
+  <mc:AlternateContent xmlns:mc="http://schemas.openxmlformats.org/markup-compatibility/2006" xmlns:p14="http://schemas.microsoft.com/office/powerpoint/2010/main">
+    <mc:Choice Requires="p14">
       <p:transition p14:dur="400">
         <p:fade/>
       </p:transition>
     </mc:Choice>
-    <mc:Fallback>
+    <mc:Fallback xmlns="">
       <p:transition>
         <p:fade/>
       </p:transition>
@@ -39527,13 +39443,13 @@
   <p:clrMapOvr>
     <a:masterClrMapping/>
   </p:clrMapOvr>
-  <mc:AlternateContent xmlns:mc="http://schemas.openxmlformats.org/markup-compatibility/2006">
-    <mc:Choice xmlns:p14="http://schemas.microsoft.com/office/powerpoint/2010/main" Requires="p14">
+  <mc:AlternateContent xmlns:mc="http://schemas.openxmlformats.org/markup-compatibility/2006" xmlns:p14="http://schemas.microsoft.com/office/powerpoint/2010/main">
+    <mc:Choice Requires="p14">
       <p:transition p14:dur="400">
         <p:fade/>
       </p:transition>
     </mc:Choice>
-    <mc:Fallback>
+    <mc:Fallback xmlns="">
       <p:transition>
         <p:fade/>
       </p:transition>
@@ -42051,13 +41967,13 @@
   <p:clrMapOvr>
     <a:masterClrMapping/>
   </p:clrMapOvr>
-  <mc:AlternateContent xmlns:mc="http://schemas.openxmlformats.org/markup-compatibility/2006">
-    <mc:Choice xmlns:p14="http://schemas.microsoft.com/office/powerpoint/2010/main" Requires="p14">
+  <mc:AlternateContent xmlns:mc="http://schemas.openxmlformats.org/markup-compatibility/2006" xmlns:p14="http://schemas.microsoft.com/office/powerpoint/2010/main">
+    <mc:Choice Requires="p14">
       <p:transition p14:dur="400">
         <p:fade/>
       </p:transition>
     </mc:Choice>
-    <mc:Fallback>
+    <mc:Fallback xmlns="">
       <p:transition>
         <p:fade/>
       </p:transition>
@@ -44525,13 +44441,13 @@
   <p:clrMapOvr>
     <a:masterClrMapping/>
   </p:clrMapOvr>
-  <mc:AlternateContent xmlns:mc="http://schemas.openxmlformats.org/markup-compatibility/2006">
-    <mc:Choice xmlns:p14="http://schemas.microsoft.com/office/powerpoint/2010/main" Requires="p14">
+  <mc:AlternateContent xmlns:mc="http://schemas.openxmlformats.org/markup-compatibility/2006" xmlns:p14="http://schemas.microsoft.com/office/powerpoint/2010/main">
+    <mc:Choice Requires="p14">
       <p:transition p14:dur="400">
         <p:fade/>
       </p:transition>
     </mc:Choice>
-    <mc:Fallback>
+    <mc:Fallback xmlns="">
       <p:transition>
         <p:fade/>
       </p:transition>

</xml_diff>

<commit_message>
Doing some last minute updates
</commit_message>
<xml_diff>
--- a/slides/Intel_CET_Linux_Summit_NA_2026.pptx
+++ b/slides/Intel_CET_Linux_Summit_NA_2026.pptx
@@ -37375,6 +37375,13 @@
               <a:noFill/>
             </a:ln>
           </p:spPr>
+          <p:txBody>
+            <a:bodyPr/>
+            <a:lstStyle/>
+            <a:p>
+              <a:endParaRPr lang="en-US" dirty="0"/>
+            </a:p>
+          </p:txBody>
         </p:sp>
         <p:sp>
           <p:nvSpPr>
@@ -37464,8 +37471,8 @@
           </p:nvSpPr>
           <p:spPr>
             <a:xfrm>
-              <a:off x="653415" y="1963102"/>
-              <a:ext cx="2418969" cy="213360"/>
+              <a:off x="691147" y="2198553"/>
+              <a:ext cx="3097002" cy="161583"/>
             </a:xfrm>
             <a:prstGeom prst="rect">
               <a:avLst/>
@@ -37491,21 +37498,43 @@
                   <a:ea typeface="Microsoft YaHei"/>
                   <a:cs typeface="Consolas"/>
                 </a:rPr>
-                <a:t>  asm volatile(                           \</a:t>
-              </a:r>
-            </a:p>
-          </p:txBody>
-        </p:sp>
-        <p:sp>
-          <p:nvSpPr>
-            <p:cNvPr id="10" name="TextBox 10"/>
-            <p:cNvSpPr txBox="1"/>
-            <p:nvPr/>
-          </p:nvSpPr>
-          <p:spPr>
-            <a:xfrm>
-              <a:off x="653415" y="2182178"/>
-              <a:ext cx="2464975" cy="213360"/>
+                <a:t>  asm (                           </a:t>
+              </a:r>
+              <a:r>
+                <a:rPr lang="en-US" altLang="zh-CN" sz="1050" dirty="0">
+                  <a:solidFill>
+                    <a:srgbClr val="E0E0E0"/>
+                  </a:solidFill>
+                  <a:latin typeface="Consolas"/>
+                  <a:ea typeface="Microsoft YaHei"/>
+                  <a:cs typeface="Consolas"/>
+                </a:rPr>
+                <a:t>       </a:t>
+              </a:r>
+              <a:r>
+                <a:rPr lang="zh-CN" sz="1050" dirty="0">
+                  <a:solidFill>
+                    <a:srgbClr val="E0E0E0"/>
+                  </a:solidFill>
+                  <a:latin typeface="Consolas"/>
+                  <a:ea typeface="Microsoft YaHei"/>
+                  <a:cs typeface="Consolas"/>
+                </a:rPr>
+                <a:t>\</a:t>
+              </a:r>
+            </a:p>
+          </p:txBody>
+        </p:sp>
+        <p:sp>
+          <p:nvSpPr>
+            <p:cNvPr id="11" name="TextBox 11"/>
+            <p:cNvSpPr txBox="1"/>
+            <p:nvPr/>
+          </p:nvSpPr>
+          <p:spPr>
+            <a:xfrm>
+              <a:off x="653415" y="2401252"/>
+              <a:ext cx="3097002" cy="161583"/>
             </a:xfrm>
             <a:prstGeom prst="rect">
               <a:avLst/>
@@ -37525,27 +37554,217 @@
               <a:r>
                 <a:rPr lang="zh-CN" sz="1050" dirty="0">
                   <a:solidFill>
+                    <a:srgbClr val="F79646"/>
+                  </a:solidFill>
+                  <a:latin typeface="Consolas"/>
+                  <a:ea typeface="Microsoft YaHei"/>
+                  <a:cs typeface="Consolas"/>
+                </a:rPr>
+                <a:t>      "mov $~0xfa1e0ff3, %[</a:t>
+              </a:r>
+              <a:r>
+                <a:rPr lang="en-US" altLang="zh-CN" sz="1050" dirty="0" err="1">
+                  <a:solidFill>
+                    <a:srgbClr val="F79646"/>
+                  </a:solidFill>
+                  <a:latin typeface="Consolas"/>
+                  <a:ea typeface="Microsoft YaHei"/>
+                  <a:cs typeface="Consolas"/>
+                </a:rPr>
+                <a:t>endbr</a:t>
+              </a:r>
+              <a:r>
+                <a:rPr lang="zh-CN" sz="1050" dirty="0">
+                  <a:solidFill>
+                    <a:srgbClr val="F79646"/>
+                  </a:solidFill>
+                  <a:latin typeface="Consolas"/>
+                  <a:ea typeface="Microsoft YaHei"/>
+                  <a:cs typeface="Consolas"/>
+                </a:rPr>
+                <a:t>]\n\t"  </a:t>
+              </a:r>
+              <a:r>
+                <a:rPr lang="en-US" altLang="zh-CN" sz="1050" dirty="0">
+                  <a:solidFill>
+                    <a:srgbClr val="F79646"/>
+                  </a:solidFill>
+                  <a:latin typeface="Consolas"/>
+                  <a:ea typeface="Microsoft YaHei"/>
+                  <a:cs typeface="Consolas"/>
+                </a:rPr>
+                <a:t> </a:t>
+              </a:r>
+              <a:r>
+                <a:rPr lang="zh-CN" sz="1050" dirty="0">
+                  <a:solidFill>
+                    <a:srgbClr val="F79646"/>
+                  </a:solidFill>
+                  <a:latin typeface="Consolas"/>
+                  <a:ea typeface="Microsoft YaHei"/>
+                  <a:cs typeface="Consolas"/>
+                </a:rPr>
+                <a:t>\</a:t>
+              </a:r>
+            </a:p>
+          </p:txBody>
+        </p:sp>
+        <p:sp>
+          <p:nvSpPr>
+            <p:cNvPr id="12" name="TextBox 12"/>
+            <p:cNvSpPr txBox="1"/>
+            <p:nvPr/>
+          </p:nvSpPr>
+          <p:spPr>
+            <a:xfrm>
+              <a:off x="653415" y="2620328"/>
+              <a:ext cx="3097002" cy="161583"/>
+            </a:xfrm>
+            <a:prstGeom prst="rect">
+              <a:avLst/>
+            </a:prstGeom>
+            <a:noFill/>
+            <a:ln>
+              <a:noFill/>
+            </a:ln>
+          </p:spPr>
+          <p:txBody>
+            <a:bodyPr wrap="none" lIns="0" tIns="0" rIns="0" bIns="0" anchor="t" anchorCtr="0">
+              <a:spAutoFit/>
+            </a:bodyPr>
+            <a:lstStyle/>
+            <a:p>
+              <a:pPr algn="l"/>
+              <a:r>
+                <a:rPr lang="zh-CN" sz="1050" dirty="0">
+                  <a:solidFill>
+                    <a:srgbClr val="F79646"/>
+                  </a:solidFill>
+                  <a:latin typeface="Consolas"/>
+                  <a:ea typeface="Microsoft YaHei"/>
+                  <a:cs typeface="Consolas"/>
+                </a:rPr>
+                <a:t>      "not %[</a:t>
+              </a:r>
+              <a:r>
+                <a:rPr lang="en-US" altLang="zh-CN" sz="1050" dirty="0" err="1">
+                  <a:solidFill>
+                    <a:srgbClr val="F79646"/>
+                  </a:solidFill>
+                  <a:latin typeface="Consolas"/>
+                  <a:ea typeface="Microsoft YaHei"/>
+                  <a:cs typeface="Consolas"/>
+                </a:rPr>
+                <a:t>endbr</a:t>
+              </a:r>
+              <a:r>
+                <a:rPr lang="zh-CN" sz="1050" dirty="0">
+                  <a:solidFill>
+                    <a:srgbClr val="F79646"/>
+                  </a:solidFill>
+                  <a:latin typeface="Consolas"/>
+                  <a:ea typeface="Microsoft YaHei"/>
+                  <a:cs typeface="Consolas"/>
+                </a:rPr>
+                <a:t>]\n\t",              </a:t>
+              </a:r>
+              <a:r>
+                <a:rPr lang="en-US" altLang="zh-CN" sz="1050" dirty="0">
+                  <a:solidFill>
+                    <a:srgbClr val="F79646"/>
+                  </a:solidFill>
+                  <a:latin typeface="Consolas"/>
+                  <a:ea typeface="Microsoft YaHei"/>
+                  <a:cs typeface="Consolas"/>
+                </a:rPr>
+                <a:t>  </a:t>
+              </a:r>
+              <a:r>
+                <a:rPr lang="zh-CN" sz="1050" dirty="0">
+                  <a:solidFill>
+                    <a:srgbClr val="F79646"/>
+                  </a:solidFill>
+                  <a:latin typeface="Consolas"/>
+                  <a:ea typeface="Microsoft YaHei"/>
+                  <a:cs typeface="Consolas"/>
+                </a:rPr>
+                <a:t>\</a:t>
+              </a:r>
+            </a:p>
+          </p:txBody>
+        </p:sp>
+        <p:sp>
+          <p:nvSpPr>
+            <p:cNvPr id="15" name="TextBox 15"/>
+            <p:cNvSpPr txBox="1"/>
+            <p:nvPr/>
+          </p:nvSpPr>
+          <p:spPr>
+            <a:xfrm>
+              <a:off x="653415" y="2826746"/>
+              <a:ext cx="1032334" cy="161583"/>
+            </a:xfrm>
+            <a:prstGeom prst="rect">
+              <a:avLst/>
+            </a:prstGeom>
+            <a:noFill/>
+            <a:ln>
+              <a:noFill/>
+            </a:ln>
+          </p:spPr>
+          <p:txBody>
+            <a:bodyPr wrap="none" lIns="0" tIns="0" rIns="0" bIns="0" anchor="t" anchorCtr="0">
+              <a:spAutoFit/>
+            </a:bodyPr>
+            <a:lstStyle/>
+            <a:p>
+              <a:pPr algn="l"/>
+              <a:r>
+                <a:rPr lang="zh-CN" sz="1050" dirty="0">
+                  <a:solidFill>
                     <a:srgbClr val="E0E0E0"/>
                   </a:solidFill>
                   <a:latin typeface="Consolas"/>
                   <a:ea typeface="Microsoft YaHei"/>
                   <a:cs typeface="Consolas"/>
                 </a:rPr>
-                <a:t>    ALTERNATIVE(                          \</a:t>
-              </a:r>
-            </a:p>
-          </p:txBody>
-        </p:sp>
-        <p:sp>
-          <p:nvSpPr>
-            <p:cNvPr id="11" name="TextBox 11"/>
-            <p:cNvSpPr txBox="1"/>
-            <p:nvPr/>
-          </p:nvSpPr>
-          <p:spPr>
-            <a:xfrm>
-              <a:off x="653415" y="2401252"/>
-              <a:ext cx="3262408" cy="213360"/>
+                <a:t>    : [</a:t>
+              </a:r>
+              <a:r>
+                <a:rPr lang="en-US" altLang="zh-CN" sz="1050" dirty="0" err="1">
+                  <a:solidFill>
+                    <a:srgbClr val="E0E0E0"/>
+                  </a:solidFill>
+                  <a:latin typeface="Consolas"/>
+                  <a:ea typeface="Microsoft YaHei"/>
+                  <a:cs typeface="Consolas"/>
+                </a:rPr>
+                <a:t>endbr</a:t>
+              </a:r>
+              <a:r>
+                <a:rPr lang="zh-CN" sz="1050" dirty="0">
+                  <a:solidFill>
+                    <a:srgbClr val="E0E0E0"/>
+                  </a:solidFill>
+                  <a:latin typeface="Consolas"/>
+                  <a:ea typeface="Microsoft YaHei"/>
+                  <a:cs typeface="Consolas"/>
+                </a:rPr>
+                <a:t>] </a:t>
+              </a:r>
+            </a:p>
+          </p:txBody>
+        </p:sp>
+        <p:sp>
+          <p:nvSpPr>
+            <p:cNvPr id="16" name="TextBox 16"/>
+            <p:cNvSpPr txBox="1"/>
+            <p:nvPr/>
+          </p:nvSpPr>
+          <p:spPr>
+            <a:xfrm>
+              <a:off x="1713610" y="2823041"/>
+              <a:ext cx="448389" cy="213360"/>
             </a:xfrm>
             <a:prstGeom prst="rect">
               <a:avLst/>
@@ -37571,21 +37790,21 @@
                   <a:ea typeface="Microsoft YaHei"/>
                   <a:cs typeface="Consolas"/>
                 </a:rPr>
-                <a:t>      "mov $~0xfa1e0ff3, %[scratch]\n\t"  \</a:t>
-              </a:r>
-            </a:p>
-          </p:txBody>
-        </p:sp>
-        <p:sp>
-          <p:nvSpPr>
-            <p:cNvPr id="12" name="TextBox 12"/>
-            <p:cNvSpPr txBox="1"/>
-            <p:nvPr/>
-          </p:nvSpPr>
-          <p:spPr>
-            <a:xfrm>
-              <a:off x="653415" y="2620328"/>
-              <a:ext cx="2764012" cy="213360"/>
+                <a:t>"=&amp;r"</a:t>
+              </a:r>
+            </a:p>
+          </p:txBody>
+        </p:sp>
+        <p:sp>
+          <p:nvSpPr>
+            <p:cNvPr id="17" name="TextBox 17"/>
+            <p:cNvSpPr txBox="1"/>
+            <p:nvPr/>
+          </p:nvSpPr>
+          <p:spPr>
+            <a:xfrm>
+              <a:off x="2049994" y="2815589"/>
+              <a:ext cx="1327286" cy="161583"/>
             </a:xfrm>
             <a:prstGeom prst="rect">
               <a:avLst/>
@@ -37605,453 +37824,35 @@
               <a:r>
                 <a:rPr lang="zh-CN" sz="1050" dirty="0">
                   <a:solidFill>
-                    <a:srgbClr val="F79646"/>
+                    <a:srgbClr val="E0E0E0"/>
                   </a:solidFill>
                   <a:latin typeface="Consolas"/>
                   <a:ea typeface="Microsoft YaHei"/>
                   <a:cs typeface="Consolas"/>
                 </a:rPr>
-                <a:t>      "not %[scratch]\n\t",              \</a:t>
-              </a:r>
-            </a:p>
-          </p:txBody>
-        </p:sp>
-        <p:sp>
-          <p:nvSpPr>
-            <p:cNvPr id="13" name="TextBox 13"/>
-            <p:cNvSpPr txBox="1"/>
-            <p:nvPr/>
-          </p:nvSpPr>
-          <p:spPr>
-            <a:xfrm>
-              <a:off x="653415" y="2839402"/>
-              <a:ext cx="2112264" cy="213360"/>
-            </a:xfrm>
-            <a:prstGeom prst="rect">
-              <a:avLst/>
-            </a:prstGeom>
-            <a:noFill/>
-            <a:ln>
-              <a:noFill/>
-            </a:ln>
-          </p:spPr>
-          <p:txBody>
-            <a:bodyPr wrap="none" lIns="0" tIns="0" rIns="0" bIns="0" anchor="t" anchorCtr="0">
-              <a:spAutoFit/>
-            </a:bodyPr>
-            <a:lstStyle/>
-            <a:p>
-              <a:pPr algn="l"/>
+                <a:t> (</a:t>
+              </a:r>
+              <a:r>
+                <a:rPr lang="en-US" altLang="zh-CN" sz="1050" dirty="0" err="1">
+                  <a:solidFill>
+                    <a:srgbClr val="E0E0E0"/>
+                  </a:solidFill>
+                  <a:latin typeface="Consolas"/>
+                  <a:ea typeface="Microsoft YaHei"/>
+                  <a:cs typeface="Consolas"/>
+                </a:rPr>
+                <a:t>endbr</a:t>
+              </a:r>
               <a:r>
                 <a:rPr lang="zh-CN" sz="1050" dirty="0">
                   <a:solidFill>
-                    <a:srgbClr val="F79646"/>
+                    <a:srgbClr val="E0E0E0"/>
                   </a:solidFill>
                   <a:latin typeface="Consolas"/>
                   <a:ea typeface="Microsoft YaHei"/>
                   <a:cs typeface="Consolas"/>
                 </a:rPr>
-                <a:t>      "",                                \</a:t>
-              </a:r>
-            </a:p>
-          </p:txBody>
-        </p:sp>
-        <p:sp>
-          <p:nvSpPr>
-            <p:cNvPr id="14" name="TextBox 14"/>
-            <p:cNvSpPr txBox="1"/>
-            <p:nvPr/>
-          </p:nvSpPr>
-          <p:spPr>
-            <a:xfrm>
-              <a:off x="653415" y="3058478"/>
-              <a:ext cx="2572321" cy="213360"/>
-            </a:xfrm>
-            <a:prstGeom prst="rect">
-              <a:avLst/>
-            </a:prstGeom>
-            <a:noFill/>
-            <a:ln>
-              <a:noFill/>
-            </a:ln>
-          </p:spPr>
-          <p:txBody>
-            <a:bodyPr wrap="none" lIns="0" tIns="0" rIns="0" bIns="0" anchor="t" anchorCtr="0">
-              <a:spAutoFit/>
-            </a:bodyPr>
-            <a:lstStyle/>
-            <a:p>
-              <a:pPr algn="l"/>
-              <a:r>
-                <a:rPr lang="zh-CN" sz="1050" dirty="0">
-                  <a:solidFill>
-                    <a:srgbClr val="E0E0E0"/>
-                  </a:solidFill>
-                  <a:latin typeface="Consolas"/>
-                  <a:ea typeface="Microsoft YaHei"/>
-                  <a:cs typeface="Consolas"/>
-                </a:rPr>
-                <a:t>      X86_FEATURE_IBT)                   \</a:t>
-              </a:r>
-            </a:p>
-          </p:txBody>
-        </p:sp>
-        <p:sp>
-          <p:nvSpPr>
-            <p:cNvPr id="15" name="TextBox 15"/>
-            <p:cNvSpPr txBox="1"/>
-            <p:nvPr/>
-          </p:nvSpPr>
-          <p:spPr>
-            <a:xfrm>
-              <a:off x="653415" y="3277552"/>
-              <a:ext cx="1146143" cy="213360"/>
-            </a:xfrm>
-            <a:prstGeom prst="rect">
-              <a:avLst/>
-            </a:prstGeom>
-            <a:noFill/>
-            <a:ln>
-              <a:noFill/>
-            </a:ln>
-          </p:spPr>
-          <p:txBody>
-            <a:bodyPr wrap="none" lIns="0" tIns="0" rIns="0" bIns="0" anchor="t" anchorCtr="0">
-              <a:spAutoFit/>
-            </a:bodyPr>
-            <a:lstStyle/>
-            <a:p>
-              <a:pPr algn="l"/>
-              <a:r>
-                <a:rPr lang="zh-CN" sz="1050" dirty="0">
-                  <a:solidFill>
-                    <a:srgbClr val="E0E0E0"/>
-                  </a:solidFill>
-                  <a:latin typeface="Consolas"/>
-                  <a:ea typeface="Microsoft YaHei"/>
-                  <a:cs typeface="Consolas"/>
-                </a:rPr>
-                <a:t>    : [scratch] </a:t>
-              </a:r>
-            </a:p>
-          </p:txBody>
-        </p:sp>
-        <p:sp>
-          <p:nvSpPr>
-            <p:cNvPr id="16" name="TextBox 16"/>
-            <p:cNvSpPr txBox="1"/>
-            <p:nvPr/>
-          </p:nvSpPr>
-          <p:spPr>
-            <a:xfrm>
-              <a:off x="2110740" y="3277552"/>
-              <a:ext cx="448389" cy="213360"/>
-            </a:xfrm>
-            <a:prstGeom prst="rect">
-              <a:avLst/>
-            </a:prstGeom>
-            <a:noFill/>
-            <a:ln>
-              <a:noFill/>
-            </a:ln>
-          </p:spPr>
-          <p:txBody>
-            <a:bodyPr wrap="none" lIns="0" tIns="0" rIns="0" bIns="0" anchor="t" anchorCtr="0">
-              <a:spAutoFit/>
-            </a:bodyPr>
-            <a:lstStyle/>
-            <a:p>
-              <a:pPr algn="l"/>
-              <a:r>
-                <a:rPr lang="zh-CN" sz="1050" dirty="0">
-                  <a:solidFill>
-                    <a:srgbClr val="F79646"/>
-                  </a:solidFill>
-                  <a:latin typeface="Consolas"/>
-                  <a:ea typeface="Microsoft YaHei"/>
-                  <a:cs typeface="Consolas"/>
-                </a:rPr>
-                <a:t>"=&amp;r"</a:t>
-              </a:r>
-            </a:p>
-          </p:txBody>
-        </p:sp>
-        <p:sp>
-          <p:nvSpPr>
-            <p:cNvPr id="17" name="TextBox 17"/>
-            <p:cNvSpPr txBox="1"/>
-            <p:nvPr/>
-          </p:nvSpPr>
-          <p:spPr>
-            <a:xfrm>
-              <a:off x="2653665" y="3277552"/>
-              <a:ext cx="1253490" cy="213360"/>
-            </a:xfrm>
-            <a:prstGeom prst="rect">
-              <a:avLst/>
-            </a:prstGeom>
-            <a:noFill/>
-            <a:ln>
-              <a:noFill/>
-            </a:ln>
-          </p:spPr>
-          <p:txBody>
-            <a:bodyPr wrap="none" lIns="0" tIns="0" rIns="0" bIns="0" anchor="t" anchorCtr="0">
-              <a:spAutoFit/>
-            </a:bodyPr>
-            <a:lstStyle/>
-            <a:p>
-              <a:pPr algn="l"/>
-              <a:r>
-                <a:rPr lang="zh-CN" sz="1050" dirty="0">
-                  <a:solidFill>
-                    <a:srgbClr val="E0E0E0"/>
-                  </a:solidFill>
-                  <a:latin typeface="Consolas"/>
-                  <a:ea typeface="Microsoft YaHei"/>
-                  <a:cs typeface="Consolas"/>
-                </a:rPr>
-                <a:t> (__junk)          \</a:t>
-              </a:r>
-            </a:p>
-          </p:txBody>
-        </p:sp>
-        <p:sp>
-          <p:nvSpPr>
-            <p:cNvPr id="18" name="TextBox 18"/>
-            <p:cNvSpPr txBox="1"/>
-            <p:nvPr/>
-          </p:nvSpPr>
-          <p:spPr>
-            <a:xfrm>
-              <a:off x="653415" y="3496628"/>
-              <a:ext cx="2035588" cy="213360"/>
-            </a:xfrm>
-            <a:prstGeom prst="rect">
-              <a:avLst/>
-            </a:prstGeom>
-            <a:noFill/>
-            <a:ln>
-              <a:noFill/>
-            </a:ln>
-          </p:spPr>
-          <p:txBody>
-            <a:bodyPr wrap="none" lIns="0" tIns="0" rIns="0" bIns="0" anchor="t" anchorCtr="0">
-              <a:spAutoFit/>
-            </a:bodyPr>
-            <a:lstStyle/>
-            <a:p>
-              <a:pPr algn="l"/>
-              <a:r>
-                <a:rPr lang="zh-CN" sz="1050" dirty="0">
-                  <a:solidFill>
-                    <a:srgbClr val="E0E0E0"/>
-                  </a:solidFill>
-                  <a:latin typeface="Consolas"/>
-                  <a:ea typeface="Microsoft YaHei"/>
-                  <a:cs typeface="Consolas"/>
-                </a:rPr>
-                <a:t>    :                                    \</a:t>
-              </a:r>
-            </a:p>
-          </p:txBody>
-        </p:sp>
-        <p:sp>
-          <p:nvSpPr>
-            <p:cNvPr id="19" name="TextBox 19"/>
-            <p:cNvSpPr txBox="1"/>
-            <p:nvPr/>
-          </p:nvSpPr>
-          <p:spPr>
-            <a:xfrm>
-              <a:off x="653415" y="3715702"/>
-              <a:ext cx="341043" cy="213360"/>
-            </a:xfrm>
-            <a:prstGeom prst="rect">
-              <a:avLst/>
-            </a:prstGeom>
-            <a:noFill/>
-            <a:ln>
-              <a:noFill/>
-            </a:ln>
-          </p:spPr>
-          <p:txBody>
-            <a:bodyPr wrap="none" lIns="0" tIns="0" rIns="0" bIns="0" anchor="t" anchorCtr="0">
-              <a:spAutoFit/>
-            </a:bodyPr>
-            <a:lstStyle/>
-            <a:p>
-              <a:pPr algn="l"/>
-              <a:r>
-                <a:rPr lang="zh-CN" sz="1050" dirty="0">
-                  <a:solidFill>
-                    <a:srgbClr val="E0E0E0"/>
-                  </a:solidFill>
-                  <a:latin typeface="Consolas"/>
-                  <a:ea typeface="Microsoft YaHei"/>
-                  <a:cs typeface="Consolas"/>
-                </a:rPr>
-                <a:t>    : </a:t>
-              </a:r>
-            </a:p>
-          </p:txBody>
-        </p:sp>
-        <p:sp>
-          <p:nvSpPr>
-            <p:cNvPr id="20" name="TextBox 20"/>
-            <p:cNvSpPr txBox="1"/>
-            <p:nvPr/>
-          </p:nvSpPr>
-          <p:spPr>
-            <a:xfrm>
-              <a:off x="1062990" y="3715702"/>
-              <a:ext cx="762762" cy="213360"/>
-            </a:xfrm>
-            <a:prstGeom prst="rect">
-              <a:avLst/>
-            </a:prstGeom>
-            <a:noFill/>
-            <a:ln>
-              <a:noFill/>
-            </a:ln>
-          </p:spPr>
-          <p:txBody>
-            <a:bodyPr wrap="none" lIns="0" tIns="0" rIns="0" bIns="0" anchor="t" anchorCtr="0">
-              <a:spAutoFit/>
-            </a:bodyPr>
-            <a:lstStyle/>
-            <a:p>
-              <a:pPr algn="l"/>
-              <a:r>
-                <a:rPr lang="zh-CN" sz="1050" dirty="0">
-                  <a:solidFill>
-                    <a:srgbClr val="F79646"/>
-                  </a:solidFill>
-                  <a:latin typeface="Consolas"/>
-                  <a:ea typeface="Microsoft YaHei"/>
-                  <a:cs typeface="Consolas"/>
-                </a:rPr>
-                <a:t>"memory"</a:t>
-              </a:r>
-            </a:p>
-          </p:txBody>
-        </p:sp>
-        <p:sp>
-          <p:nvSpPr>
-            <p:cNvPr id="21" name="TextBox 21"/>
-            <p:cNvSpPr txBox="1"/>
-            <p:nvPr/>
-          </p:nvSpPr>
-          <p:spPr>
-            <a:xfrm>
-              <a:off x="1796415" y="3715702"/>
-              <a:ext cx="195358" cy="213360"/>
-            </a:xfrm>
-            <a:prstGeom prst="rect">
-              <a:avLst/>
-            </a:prstGeom>
-            <a:noFill/>
-            <a:ln>
-              <a:noFill/>
-            </a:ln>
-          </p:spPr>
-          <p:txBody>
-            <a:bodyPr wrap="none" lIns="0" tIns="0" rIns="0" bIns="0" anchor="t" anchorCtr="0">
-              <a:spAutoFit/>
-            </a:bodyPr>
-            <a:lstStyle/>
-            <a:p>
-              <a:pPr algn="l"/>
-              <a:r>
-                <a:rPr lang="zh-CN" sz="1050" dirty="0">
-                  <a:solidFill>
-                    <a:srgbClr val="E0E0E0"/>
-                  </a:solidFill>
-                  <a:latin typeface="Consolas"/>
-                  <a:ea typeface="Microsoft YaHei"/>
-                  <a:cs typeface="Consolas"/>
-                </a:rPr>
-                <a:t>);</a:t>
-              </a:r>
-            </a:p>
-          </p:txBody>
-        </p:sp>
-        <p:sp>
-          <p:nvSpPr>
-            <p:cNvPr id="22" name="TextBox 22"/>
-            <p:cNvSpPr txBox="1"/>
-            <p:nvPr/>
-          </p:nvSpPr>
-          <p:spPr>
-            <a:xfrm>
-              <a:off x="653415" y="4077652"/>
-              <a:ext cx="3837480" cy="213360"/>
-            </a:xfrm>
-            <a:prstGeom prst="rect">
-              <a:avLst/>
-            </a:prstGeom>
-            <a:noFill/>
-            <a:ln>
-              <a:noFill/>
-            </a:ln>
-          </p:spPr>
-          <p:txBody>
-            <a:bodyPr wrap="none" lIns="0" tIns="0" rIns="0" bIns="0" anchor="t" anchorCtr="0">
-              <a:spAutoFit/>
-            </a:bodyPr>
-            <a:lstStyle/>
-            <a:p>
-              <a:pPr algn="l"/>
-              <a:r>
-                <a:rPr lang="zh-CN" sz="1050" dirty="0">
-                  <a:solidFill>
-                    <a:srgbClr val="6A9955"/>
-                  </a:solidFill>
-                  <a:latin typeface="Consolas"/>
-                  <a:ea typeface="Microsoft YaHei"/>
-                  <a:cs typeface="Consolas"/>
-                </a:rPr>
-                <a:t>/* On non-IBT CPUs: ALTERNATIVE patches to NOP */</a:t>
-              </a:r>
-            </a:p>
-          </p:txBody>
-        </p:sp>
-        <p:sp>
-          <p:nvSpPr>
-            <p:cNvPr id="23" name="TextBox 23"/>
-            <p:cNvSpPr txBox="1"/>
-            <p:nvPr/>
-          </p:nvSpPr>
-          <p:spPr>
-            <a:xfrm>
-              <a:off x="653415" y="4296728"/>
-              <a:ext cx="3960162" cy="213360"/>
-            </a:xfrm>
-            <a:prstGeom prst="rect">
-              <a:avLst/>
-            </a:prstGeom>
-            <a:noFill/>
-            <a:ln>
-              <a:noFill/>
-            </a:ln>
-          </p:spPr>
-          <p:txBody>
-            <a:bodyPr wrap="none" lIns="0" tIns="0" rIns="0" bIns="0" anchor="t" anchorCtr="0">
-              <a:spAutoFit/>
-            </a:bodyPr>
-            <a:lstStyle/>
-            <a:p>
-              <a:pPr algn="l"/>
-              <a:r>
-                <a:rPr lang="zh-CN" sz="1050" dirty="0">
-                  <a:solidFill>
-                    <a:srgbClr val="6A9955"/>
-                  </a:solidFill>
-                  <a:latin typeface="Consolas"/>
-                  <a:ea typeface="Microsoft YaHei"/>
-                  <a:cs typeface="Consolas"/>
-                </a:rPr>
-                <a:t>/* On IBT CPUs: mov+not produces ENDBR64 opcode */</a:t>
+                <a:t>)          </a:t>
               </a:r>
             </a:p>
           </p:txBody>
@@ -38791,235 +38592,6 @@
         </p:sp>
         <p:sp>
           <p:nvSpPr>
-            <p:cNvPr id="44" name="Rectangle 44"/>
-            <p:cNvSpPr/>
-            <p:nvPr/>
-          </p:nvSpPr>
-          <p:spPr>
-            <a:xfrm>
-              <a:off x="7429500" y="3762375"/>
-              <a:ext cx="4286250" cy="666750"/>
-            </a:xfrm>
-            <a:prstGeom prst="roundRect">
-              <a:avLst>
-                <a:gd name="adj" fmla="val 8571"/>
-              </a:avLst>
-            </a:prstGeom>
-            <a:solidFill>
-              <a:srgbClr val="FAF5FF"/>
-            </a:solidFill>
-            <a:ln w="14288">
-              <a:solidFill>
-                <a:srgbClr val="AF00C0"/>
-              </a:solidFill>
-            </a:ln>
-          </p:spPr>
-        </p:sp>
-        <p:grpSp>
-          <p:nvGrpSpPr>
-            <p:cNvPr id="47" name="Group 47"/>
-            <p:cNvGrpSpPr/>
-            <p:nvPr/>
-          </p:nvGrpSpPr>
-          <p:grpSpPr>
-            <a:xfrm>
-              <a:off x="7596188" y="3943350"/>
-              <a:ext cx="180975" cy="152400"/>
-              <a:chOff x="7596188" y="3943350"/>
-              <a:chExt cx="180975" cy="152400"/>
-            </a:xfrm>
-          </p:grpSpPr>
-          <p:sp>
-            <p:nvSpPr>
-              <p:cNvPr id="45" name="Freeform 45"/>
-              <p:cNvSpPr/>
-              <p:nvPr/>
-            </p:nvSpPr>
-            <p:spPr>
-              <a:xfrm>
-                <a:off x="7596188" y="3943350"/>
-                <a:ext cx="180975" cy="152400"/>
-              </a:xfrm>
-              <a:custGeom>
-                <a:avLst/>
-                <a:gdLst/>
-                <a:ahLst/>
-                <a:cxnLst/>
-                <a:rect l="l" t="t" r="r" b="b"/>
-                <a:pathLst>
-                  <a:path w="180975" h="152400">
-                    <a:moveTo>
-                      <a:pt x="23812" y="0"/>
-                    </a:moveTo>
-                    <a:cubicBezTo>
-                      <a:pt x="0" y="47625"/>
-                      <a:pt x="0" y="95250"/>
-                      <a:pt x="23812" y="152400"/>
-                    </a:cubicBezTo>
-                    <a:moveTo>
-                      <a:pt x="157162" y="0"/>
-                    </a:moveTo>
-                    <a:cubicBezTo>
-                      <a:pt x="180975" y="47625"/>
-                      <a:pt x="180975" y="95250"/>
-                      <a:pt x="157162" y="152400"/>
-                    </a:cubicBezTo>
-                    <a:moveTo>
-                      <a:pt x="61912" y="47625"/>
-                    </a:moveTo>
-                    <a:lnTo>
-                      <a:pt x="71438" y="47625"/>
-                    </a:lnTo>
-                    <a:cubicBezTo>
-                      <a:pt x="80962" y="47625"/>
-                      <a:pt x="80962" y="57150"/>
-                      <a:pt x="90640" y="81220"/>
-                    </a:cubicBezTo>
-                    <a:cubicBezTo>
-                      <a:pt x="100012" y="104775"/>
-                      <a:pt x="100012" y="114300"/>
-                      <a:pt x="109538" y="114300"/>
-                    </a:cubicBezTo>
-                    <a:lnTo>
-                      <a:pt x="119062" y="114300"/>
-                    </a:lnTo>
-                  </a:path>
-                </a:pathLst>
-              </a:custGeom>
-              <a:noFill/>
-              <a:ln w="19050">
-                <a:solidFill>
-                  <a:srgbClr val="AF00C0"/>
-                </a:solidFill>
-              </a:ln>
-            </p:spPr>
-          </p:sp>
-          <p:sp>
-            <p:nvSpPr>
-              <p:cNvPr id="46" name="Freeform 46"/>
-              <p:cNvSpPr/>
-              <p:nvPr/>
-            </p:nvSpPr>
-            <p:spPr>
-              <a:xfrm>
-                <a:off x="7648575" y="3990975"/>
-                <a:ext cx="76200" cy="66675"/>
-              </a:xfrm>
-              <a:custGeom>
-                <a:avLst/>
-                <a:gdLst/>
-                <a:ahLst/>
-                <a:cxnLst/>
-                <a:rect l="l" t="t" r="r" b="b"/>
-                <a:pathLst>
-                  <a:path w="76200" h="66675">
-                    <a:moveTo>
-                      <a:pt x="0" y="66675"/>
-                    </a:moveTo>
-                    <a:cubicBezTo>
-                      <a:pt x="14288" y="66675"/>
-                      <a:pt x="28575" y="47625"/>
-                      <a:pt x="38100" y="33338"/>
-                    </a:cubicBezTo>
-                    <a:cubicBezTo>
-                      <a:pt x="47625" y="19050"/>
-                      <a:pt x="61912" y="0"/>
-                      <a:pt x="76200" y="0"/>
-                    </a:cubicBezTo>
-                  </a:path>
-                </a:pathLst>
-              </a:custGeom>
-              <a:noFill/>
-              <a:ln w="19050">
-                <a:solidFill>
-                  <a:srgbClr val="AF00C0"/>
-                </a:solidFill>
-              </a:ln>
-            </p:spPr>
-          </p:sp>
-        </p:grpSp>
-        <p:sp>
-          <p:nvSpPr>
-            <p:cNvPr id="48" name="TextBox 48"/>
-            <p:cNvSpPr txBox="1"/>
-            <p:nvPr/>
-          </p:nvSpPr>
-          <p:spPr>
-            <a:xfrm>
-              <a:off x="7873365" y="3953828"/>
-              <a:ext cx="1588565" cy="213360"/>
-            </a:xfrm>
-            <a:prstGeom prst="rect">
-              <a:avLst/>
-            </a:prstGeom>
-            <a:noFill/>
-            <a:ln>
-              <a:noFill/>
-            </a:ln>
-          </p:spPr>
-          <p:txBody>
-            <a:bodyPr wrap="none" lIns="0" tIns="0" rIns="0" bIns="0" anchor="t" anchorCtr="0">
-              <a:spAutoFit/>
-            </a:bodyPr>
-            <a:lstStyle/>
-            <a:p>
-              <a:pPr algn="l"/>
-              <a:r>
-                <a:rPr lang="zh-CN" sz="1050" b="1" dirty="0">
-                  <a:solidFill>
-                    <a:srgbClr val="AF00C0"/>
-                  </a:solidFill>
-                  <a:latin typeface="Arial"/>
-                  <a:ea typeface="Microsoft YaHei"/>
-                  <a:cs typeface="Arial"/>
-                </a:rPr>
-                <a:t>"=&amp;r" early-clobber</a:t>
-              </a:r>
-            </a:p>
-          </p:txBody>
-        </p:sp>
-        <p:sp>
-          <p:nvSpPr>
-            <p:cNvPr id="49" name="TextBox 49"/>
-            <p:cNvSpPr txBox="1"/>
-            <p:nvPr/>
-          </p:nvSpPr>
-          <p:spPr>
-            <a:xfrm>
-              <a:off x="7559992" y="4200049"/>
-              <a:ext cx="3477935" cy="198120"/>
-            </a:xfrm>
-            <a:prstGeom prst="rect">
-              <a:avLst/>
-            </a:prstGeom>
-            <a:noFill/>
-            <a:ln>
-              <a:noFill/>
-            </a:ln>
-          </p:spPr>
-          <p:txBody>
-            <a:bodyPr wrap="none" lIns="0" tIns="0" rIns="0" bIns="0" anchor="t" anchorCtr="0">
-              <a:spAutoFit/>
-            </a:bodyPr>
-            <a:lstStyle/>
-            <a:p>
-              <a:pPr algn="l"/>
-              <a:r>
-                <a:rPr lang="zh-CN" sz="975" dirty="0">
-                  <a:solidFill>
-                    <a:srgbClr val="555555"/>
-                  </a:solidFill>
-                  <a:latin typeface="Arial"/>
-                  <a:ea typeface="Microsoft YaHei"/>
-                  <a:cs typeface="Arial"/>
-                </a:rPr>
-                <a:t>Scratch register written before inputs consumed</a:t>
-              </a:r>
-            </a:p>
-          </p:txBody>
-        </p:sp>
-        <p:sp>
-          <p:nvSpPr>
             <p:cNvPr id="50" name="Rectangle 50"/>
             <p:cNvSpPr/>
             <p:nvPr/>
@@ -39438,6 +39010,52 @@
           </p:txBody>
         </p:sp>
       </p:grpSp>
+      <p:sp>
+        <p:nvSpPr>
+          <p:cNvPr id="64" name="TextBox 21">
+            <a:extLst>
+              <a:ext uri="{FF2B5EF4-FFF2-40B4-BE49-F238E27FC236}">
+                <a16:creationId xmlns:a16="http://schemas.microsoft.com/office/drawing/2014/main" id="{1197BD67-83DF-CAC7-8631-8573AF7D6CB6}"/>
+              </a:ext>
+            </a:extLst>
+          </p:cNvPr>
+          <p:cNvSpPr txBox="1"/>
+          <p:nvPr/>
+        </p:nvSpPr>
+        <p:spPr>
+          <a:xfrm>
+            <a:off x="2633913" y="2823041"/>
+            <a:ext cx="195358" cy="213360"/>
+          </a:xfrm>
+          <a:prstGeom prst="rect">
+            <a:avLst/>
+          </a:prstGeom>
+          <a:noFill/>
+          <a:ln>
+            <a:noFill/>
+          </a:ln>
+        </p:spPr>
+        <p:txBody>
+          <a:bodyPr wrap="none" lIns="0" tIns="0" rIns="0" bIns="0" anchor="t" anchorCtr="0">
+            <a:spAutoFit/>
+          </a:bodyPr>
+          <a:lstStyle/>
+          <a:p>
+            <a:pPr algn="l"/>
+            <a:r>
+              <a:rPr lang="zh-CN" sz="1050" dirty="0">
+                <a:solidFill>
+                  <a:srgbClr val="E0E0E0"/>
+                </a:solidFill>
+                <a:latin typeface="Consolas"/>
+                <a:ea typeface="Microsoft YaHei"/>
+                <a:cs typeface="Consolas"/>
+              </a:rPr>
+              <a:t>);</a:t>
+            </a:r>
+          </a:p>
+        </p:txBody>
+      </p:sp>
     </p:spTree>
   </p:cSld>
   <p:clrMapOvr>
@@ -42192,2171 +41810,6 @@
       </p:sp>
       <p:grpSp>
         <p:nvGrpSpPr>
-          <p:cNvPr id="62" name="Group 62"/>
-          <p:cNvGrpSpPr/>
-          <p:nvPr/>
-        </p:nvGrpSpPr>
-        <p:grpSpPr>
-          <a:xfrm>
-            <a:off x="476250" y="1333500"/>
-            <a:ext cx="11239500" cy="4448175"/>
-            <a:chOff x="476250" y="1333500"/>
-            <a:chExt cx="11239500" cy="4448175"/>
-          </a:xfrm>
-        </p:grpSpPr>
-        <p:sp>
-          <p:nvSpPr>
-            <p:cNvPr id="6" name="Rectangle 6"/>
-            <p:cNvSpPr/>
-            <p:nvPr/>
-          </p:nvSpPr>
-          <p:spPr>
-            <a:xfrm>
-              <a:off x="476250" y="1333500"/>
-              <a:ext cx="6858000" cy="3476625"/>
-            </a:xfrm>
-            <a:prstGeom prst="roundRect">
-              <a:avLst>
-                <a:gd name="adj" fmla="val 2192"/>
-              </a:avLst>
-            </a:prstGeom>
-            <a:solidFill>
-              <a:srgbClr val="1E293B"/>
-            </a:solidFill>
-            <a:ln>
-              <a:noFill/>
-            </a:ln>
-          </p:spPr>
-        </p:sp>
-        <p:sp>
-          <p:nvSpPr>
-            <p:cNvPr id="7" name="TextBox 7"/>
-            <p:cNvSpPr txBox="1"/>
-            <p:nvPr/>
-          </p:nvSpPr>
-          <p:spPr>
-            <a:xfrm>
-              <a:off x="655320" y="1503045"/>
-              <a:ext cx="2691193" cy="182880"/>
-            </a:xfrm>
-            <a:prstGeom prst="rect">
-              <a:avLst/>
-            </a:prstGeom>
-            <a:noFill/>
-            <a:ln>
-              <a:noFill/>
-            </a:ln>
-          </p:spPr>
-          <p:txBody>
-            <a:bodyPr wrap="none" lIns="0" tIns="0" rIns="0" bIns="0" anchor="t" anchorCtr="0">
-              <a:spAutoFit/>
-            </a:bodyPr>
-            <a:lstStyle/>
-            <a:p>
-              <a:pPr algn="l"/>
-              <a:r>
-                <a:rPr lang="zh-CN" sz="900" dirty="0">
-                  <a:solidFill>
-                    <a:srgbClr val="6A9955"/>
-                  </a:solidFill>
-                  <a:latin typeface="Arial"/>
-                  <a:ea typeface="Microsoft YaHei"/>
-                  <a:cs typeface="Arial"/>
-                </a:rPr>
-                <a:t>/* arch/x86/kernel/cet.c lines 149–162 */</a:t>
-              </a:r>
-            </a:p>
-          </p:txBody>
-        </p:sp>
-        <p:sp>
-          <p:nvSpPr>
-            <p:cNvPr id="8" name="TextBox 8"/>
-            <p:cNvSpPr txBox="1"/>
-            <p:nvPr/>
-          </p:nvSpPr>
-          <p:spPr>
-            <a:xfrm>
-              <a:off x="653415" y="1791652"/>
-              <a:ext cx="2119932" cy="213360"/>
-            </a:xfrm>
-            <a:prstGeom prst="rect">
-              <a:avLst/>
-            </a:prstGeom>
-            <a:noFill/>
-            <a:ln>
-              <a:noFill/>
-            </a:ln>
-          </p:spPr>
-          <p:txBody>
-            <a:bodyPr wrap="none" lIns="0" tIns="0" rIns="0" bIns="0" anchor="t" anchorCtr="0">
-              <a:spAutoFit/>
-            </a:bodyPr>
-            <a:lstStyle/>
-            <a:p>
-              <a:pPr algn="l"/>
-              <a:r>
-                <a:rPr lang="zh-CN" sz="1050" dirty="0">
-                  <a:solidFill>
-                    <a:srgbClr val="0AB36E"/>
-                  </a:solidFill>
-                  <a:latin typeface="Consolas"/>
-                  <a:ea typeface="Microsoft YaHei"/>
-                  <a:cs typeface="Consolas"/>
-                </a:rPr>
-                <a:t>DEFINE_IDTENTRY_ERRORCODE</a:t>
-              </a:r>
-            </a:p>
-          </p:txBody>
-        </p:sp>
-        <p:sp>
-          <p:nvSpPr>
-            <p:cNvPr id="9" name="TextBox 9"/>
-            <p:cNvSpPr txBox="1"/>
-            <p:nvPr/>
-          </p:nvSpPr>
-          <p:spPr>
-            <a:xfrm>
-              <a:off x="2796540" y="1791652"/>
-              <a:ext cx="1974247" cy="213360"/>
-            </a:xfrm>
-            <a:prstGeom prst="rect">
-              <a:avLst/>
-            </a:prstGeom>
-            <a:noFill/>
-            <a:ln>
-              <a:noFill/>
-            </a:ln>
-          </p:spPr>
-          <p:txBody>
-            <a:bodyPr wrap="none" lIns="0" tIns="0" rIns="0" bIns="0" anchor="t" anchorCtr="0">
-              <a:spAutoFit/>
-            </a:bodyPr>
-            <a:lstStyle/>
-            <a:p>
-              <a:pPr algn="l"/>
-              <a:r>
-                <a:rPr lang="zh-CN" sz="1050" dirty="0">
-                  <a:solidFill>
-                    <a:srgbClr val="E0E0E0"/>
-                  </a:solidFill>
-                  <a:latin typeface="Consolas"/>
-                  <a:ea typeface="Microsoft YaHei"/>
-                  <a:cs typeface="Consolas"/>
-                </a:rPr>
-                <a:t>(exc_control_protection)</a:t>
-              </a:r>
-            </a:p>
-          </p:txBody>
-        </p:sp>
-        <p:sp>
-          <p:nvSpPr>
-            <p:cNvPr id="10" name="TextBox 10"/>
-            <p:cNvSpPr txBox="1"/>
-            <p:nvPr/>
-          </p:nvSpPr>
-          <p:spPr>
-            <a:xfrm>
-              <a:off x="653415" y="2010728"/>
-              <a:ext cx="111014" cy="213360"/>
-            </a:xfrm>
-            <a:prstGeom prst="rect">
-              <a:avLst/>
-            </a:prstGeom>
-            <a:noFill/>
-            <a:ln>
-              <a:noFill/>
-            </a:ln>
-          </p:spPr>
-          <p:txBody>
-            <a:bodyPr wrap="none" lIns="0" tIns="0" rIns="0" bIns="0" anchor="t" anchorCtr="0">
-              <a:spAutoFit/>
-            </a:bodyPr>
-            <a:lstStyle/>
-            <a:p>
-              <a:pPr algn="l"/>
-              <a:r>
-                <a:rPr lang="zh-CN" sz="1050" dirty="0">
-                  <a:solidFill>
-                    <a:srgbClr val="E0E0E0"/>
-                  </a:solidFill>
-                  <a:latin typeface="Consolas"/>
-                  <a:ea typeface="Microsoft YaHei"/>
-                  <a:cs typeface="Consolas"/>
-                </a:rPr>
-                <a:t>{</a:t>
-              </a:r>
-            </a:p>
-          </p:txBody>
-        </p:sp>
-        <p:sp>
-          <p:nvSpPr>
-            <p:cNvPr id="11" name="TextBox 11"/>
-            <p:cNvSpPr txBox="1"/>
-            <p:nvPr/>
-          </p:nvSpPr>
-          <p:spPr>
-            <a:xfrm>
-              <a:off x="1062990" y="2258378"/>
-              <a:ext cx="157020" cy="213360"/>
-            </a:xfrm>
-            <a:prstGeom prst="rect">
-              <a:avLst/>
-            </a:prstGeom>
-            <a:noFill/>
-            <a:ln>
-              <a:noFill/>
-            </a:ln>
-          </p:spPr>
-          <p:txBody>
-            <a:bodyPr wrap="none" lIns="0" tIns="0" rIns="0" bIns="0" anchor="t" anchorCtr="0">
-              <a:spAutoFit/>
-            </a:bodyPr>
-            <a:lstStyle/>
-            <a:p>
-              <a:pPr algn="l"/>
-              <a:r>
-                <a:rPr lang="zh-CN" sz="1050" dirty="0">
-                  <a:solidFill>
-                    <a:srgbClr val="0AB36E"/>
-                  </a:solidFill>
-                  <a:latin typeface="Consolas"/>
-                  <a:ea typeface="Microsoft YaHei"/>
-                  <a:cs typeface="Consolas"/>
-                </a:rPr>
-                <a:t>if</a:t>
-              </a:r>
-            </a:p>
-          </p:txBody>
-        </p:sp>
-        <p:sp>
-          <p:nvSpPr>
-            <p:cNvPr id="12" name="TextBox 12"/>
-            <p:cNvSpPr txBox="1"/>
-            <p:nvPr/>
-          </p:nvSpPr>
-          <p:spPr>
-            <a:xfrm>
-              <a:off x="1224915" y="2258378"/>
-              <a:ext cx="3331416" cy="213360"/>
-            </a:xfrm>
-            <a:prstGeom prst="rect">
-              <a:avLst/>
-            </a:prstGeom>
-            <a:noFill/>
-            <a:ln>
-              <a:noFill/>
-            </a:ln>
-          </p:spPr>
-          <p:txBody>
-            <a:bodyPr wrap="none" lIns="0" tIns="0" rIns="0" bIns="0" anchor="t" anchorCtr="0">
-              <a:spAutoFit/>
-            </a:bodyPr>
-            <a:lstStyle/>
-            <a:p>
-              <a:pPr algn="l"/>
-              <a:r>
-                <a:rPr lang="zh-CN" sz="1050" dirty="0">
-                  <a:solidFill>
-                    <a:srgbClr val="E0E0E0"/>
-                  </a:solidFill>
-                  <a:latin typeface="Consolas"/>
-                  <a:ea typeface="Microsoft YaHei"/>
-                  <a:cs typeface="Consolas"/>
-                </a:rPr>
-                <a:t>(!cpu_feature_enabled(X86_FEATURE_IBT)) {</a:t>
-              </a:r>
-            </a:p>
-          </p:txBody>
-        </p:sp>
-        <p:sp>
-          <p:nvSpPr>
-            <p:cNvPr id="13" name="TextBox 13"/>
-            <p:cNvSpPr txBox="1"/>
-            <p:nvPr/>
-          </p:nvSpPr>
-          <p:spPr>
-            <a:xfrm>
-              <a:off x="653415" y="2477452"/>
-              <a:ext cx="985123" cy="213360"/>
-            </a:xfrm>
-            <a:prstGeom prst="rect">
-              <a:avLst/>
-            </a:prstGeom>
-            <a:noFill/>
-            <a:ln>
-              <a:noFill/>
-            </a:ln>
-          </p:spPr>
-          <p:txBody>
-            <a:bodyPr wrap="none" lIns="0" tIns="0" rIns="0" bIns="0" anchor="t" anchorCtr="0">
-              <a:spAutoFit/>
-            </a:bodyPr>
-            <a:lstStyle/>
-            <a:p>
-              <a:pPr algn="l"/>
-              <a:r>
-                <a:rPr lang="zh-CN" sz="1050" dirty="0">
-                  <a:solidFill>
-                    <a:srgbClr val="E0E0E0"/>
-                  </a:solidFill>
-                  <a:latin typeface="Consolas"/>
-                  <a:ea typeface="Microsoft YaHei"/>
-                  <a:cs typeface="Consolas"/>
-                </a:rPr>
-                <a:t>        pr_err(</a:t>
-              </a:r>
-            </a:p>
-          </p:txBody>
-        </p:sp>
-        <p:sp>
-          <p:nvSpPr>
-            <p:cNvPr id="14" name="TextBox 14"/>
-            <p:cNvSpPr txBox="1"/>
-            <p:nvPr/>
-          </p:nvSpPr>
-          <p:spPr>
-            <a:xfrm>
-              <a:off x="1796415" y="2477452"/>
-              <a:ext cx="1506522" cy="213360"/>
-            </a:xfrm>
-            <a:prstGeom prst="rect">
-              <a:avLst/>
-            </a:prstGeom>
-            <a:noFill/>
-            <a:ln>
-              <a:noFill/>
-            </a:ln>
-          </p:spPr>
-          <p:txBody>
-            <a:bodyPr wrap="none" lIns="0" tIns="0" rIns="0" bIns="0" anchor="t" anchorCtr="0">
-              <a:spAutoFit/>
-            </a:bodyPr>
-            <a:lstStyle/>
-            <a:p>
-              <a:pPr algn="l"/>
-              <a:r>
-                <a:rPr lang="zh-CN" sz="1050" dirty="0">
-                  <a:solidFill>
-                    <a:srgbClr val="F79646"/>
-                  </a:solidFill>
-                  <a:latin typeface="Consolas"/>
-                  <a:ea typeface="Microsoft YaHei"/>
-                  <a:cs typeface="Consolas"/>
-                </a:rPr>
-                <a:t>"unexpected #CP\n"</a:t>
-              </a:r>
-            </a:p>
-          </p:txBody>
-        </p:sp>
-        <p:sp>
-          <p:nvSpPr>
-            <p:cNvPr id="15" name="TextBox 15"/>
-            <p:cNvSpPr txBox="1"/>
-            <p:nvPr/>
-          </p:nvSpPr>
-          <p:spPr>
-            <a:xfrm>
-              <a:off x="3463290" y="2477452"/>
-              <a:ext cx="195358" cy="213360"/>
-            </a:xfrm>
-            <a:prstGeom prst="rect">
-              <a:avLst/>
-            </a:prstGeom>
-            <a:noFill/>
-            <a:ln>
-              <a:noFill/>
-            </a:ln>
-          </p:spPr>
-          <p:txBody>
-            <a:bodyPr wrap="none" lIns="0" tIns="0" rIns="0" bIns="0" anchor="t" anchorCtr="0">
-              <a:spAutoFit/>
-            </a:bodyPr>
-            <a:lstStyle/>
-            <a:p>
-              <a:pPr algn="l"/>
-              <a:r>
-                <a:rPr lang="zh-CN" sz="1050" dirty="0">
-                  <a:solidFill>
-                    <a:srgbClr val="E0E0E0"/>
-                  </a:solidFill>
-                  <a:latin typeface="Consolas"/>
-                  <a:ea typeface="Microsoft YaHei"/>
-                  <a:cs typeface="Consolas"/>
-                </a:rPr>
-                <a:t>);</a:t>
-              </a:r>
-            </a:p>
-          </p:txBody>
-        </p:sp>
-        <p:sp>
-          <p:nvSpPr>
-            <p:cNvPr id="16" name="TextBox 16"/>
-            <p:cNvSpPr txBox="1"/>
-            <p:nvPr/>
-          </p:nvSpPr>
-          <p:spPr>
-            <a:xfrm>
-              <a:off x="653415" y="2696528"/>
-              <a:ext cx="900779" cy="213360"/>
-            </a:xfrm>
-            <a:prstGeom prst="rect">
-              <a:avLst/>
-            </a:prstGeom>
-            <a:noFill/>
-            <a:ln>
-              <a:noFill/>
-            </a:ln>
-          </p:spPr>
-          <p:txBody>
-            <a:bodyPr wrap="none" lIns="0" tIns="0" rIns="0" bIns="0" anchor="t" anchorCtr="0">
-              <a:spAutoFit/>
-            </a:bodyPr>
-            <a:lstStyle/>
-            <a:p>
-              <a:pPr algn="l"/>
-              <a:r>
-                <a:rPr lang="zh-CN" sz="1050" dirty="0">
-                  <a:solidFill>
-                    <a:srgbClr val="E0E0E0"/>
-                  </a:solidFill>
-                  <a:latin typeface="Consolas"/>
-                  <a:ea typeface="Microsoft YaHei"/>
-                  <a:cs typeface="Consolas"/>
-                </a:rPr>
-                <a:t>        BUG();</a:t>
-              </a:r>
-            </a:p>
-          </p:txBody>
-        </p:sp>
-        <p:sp>
-          <p:nvSpPr>
-            <p:cNvPr id="17" name="TextBox 17"/>
-            <p:cNvSpPr txBox="1"/>
-            <p:nvPr/>
-          </p:nvSpPr>
-          <p:spPr>
-            <a:xfrm>
-              <a:off x="653415" y="2915602"/>
-              <a:ext cx="295037" cy="213360"/>
-            </a:xfrm>
-            <a:prstGeom prst="rect">
-              <a:avLst/>
-            </a:prstGeom>
-            <a:noFill/>
-            <a:ln>
-              <a:noFill/>
-            </a:ln>
-          </p:spPr>
-          <p:txBody>
-            <a:bodyPr wrap="none" lIns="0" tIns="0" rIns="0" bIns="0" anchor="t" anchorCtr="0">
-              <a:spAutoFit/>
-            </a:bodyPr>
-            <a:lstStyle/>
-            <a:p>
-              <a:pPr algn="l"/>
-              <a:r>
-                <a:rPr lang="zh-CN" sz="1050" dirty="0">
-                  <a:solidFill>
-                    <a:srgbClr val="E0E0E0"/>
-                  </a:solidFill>
-                  <a:latin typeface="Consolas"/>
-                  <a:ea typeface="Microsoft YaHei"/>
-                  <a:cs typeface="Consolas"/>
-                </a:rPr>
-                <a:t>    }</a:t>
-              </a:r>
-            </a:p>
-          </p:txBody>
-        </p:sp>
-        <p:sp>
-          <p:nvSpPr>
-            <p:cNvPr id="18" name="TextBox 18"/>
-            <p:cNvSpPr txBox="1"/>
-            <p:nvPr/>
-          </p:nvSpPr>
-          <p:spPr>
-            <a:xfrm>
-              <a:off x="1062990" y="3201352"/>
-              <a:ext cx="157020" cy="213360"/>
-            </a:xfrm>
-            <a:prstGeom prst="rect">
-              <a:avLst/>
-            </a:prstGeom>
-            <a:noFill/>
-            <a:ln>
-              <a:noFill/>
-            </a:ln>
-          </p:spPr>
-          <p:txBody>
-            <a:bodyPr wrap="none" lIns="0" tIns="0" rIns="0" bIns="0" anchor="t" anchorCtr="0">
-              <a:spAutoFit/>
-            </a:bodyPr>
-            <a:lstStyle/>
-            <a:p>
-              <a:pPr algn="l"/>
-              <a:r>
-                <a:rPr lang="zh-CN" sz="1050" dirty="0">
-                  <a:solidFill>
-                    <a:srgbClr val="0AB36E"/>
-                  </a:solidFill>
-                  <a:latin typeface="Consolas"/>
-                  <a:ea typeface="Microsoft YaHei"/>
-                  <a:cs typeface="Consolas"/>
-                </a:rPr>
-                <a:t>if</a:t>
-              </a:r>
-            </a:p>
-          </p:txBody>
-        </p:sp>
-        <p:sp>
-          <p:nvSpPr>
-            <p:cNvPr id="19" name="TextBox 19"/>
-            <p:cNvSpPr txBox="1"/>
-            <p:nvPr/>
-          </p:nvSpPr>
-          <p:spPr>
-            <a:xfrm>
-              <a:off x="1224915" y="3201352"/>
-              <a:ext cx="1621536" cy="213360"/>
-            </a:xfrm>
-            <a:prstGeom prst="rect">
-              <a:avLst/>
-            </a:prstGeom>
-            <a:noFill/>
-            <a:ln>
-              <a:noFill/>
-            </a:ln>
-          </p:spPr>
-          <p:txBody>
-            <a:bodyPr wrap="none" lIns="0" tIns="0" rIns="0" bIns="0" anchor="t" anchorCtr="0">
-              <a:spAutoFit/>
-            </a:bodyPr>
-            <a:lstStyle/>
-            <a:p>
-              <a:pPr algn="l"/>
-              <a:r>
-                <a:rPr lang="zh-CN" sz="1050" dirty="0">
-                  <a:solidFill>
-                    <a:srgbClr val="E0E0E0"/>
-                  </a:solidFill>
-                  <a:latin typeface="Consolas"/>
-                  <a:ea typeface="Microsoft YaHei"/>
-                  <a:cs typeface="Consolas"/>
-                </a:rPr>
-                <a:t>(user_mode(regs)) {</a:t>
-              </a:r>
-            </a:p>
-          </p:txBody>
-        </p:sp>
-        <p:sp>
-          <p:nvSpPr>
-            <p:cNvPr id="20" name="TextBox 20"/>
-            <p:cNvSpPr txBox="1"/>
-            <p:nvPr/>
-          </p:nvSpPr>
-          <p:spPr>
-            <a:xfrm>
-              <a:off x="653415" y="3420428"/>
-              <a:ext cx="3277743" cy="213360"/>
-            </a:xfrm>
-            <a:prstGeom prst="rect">
-              <a:avLst/>
-            </a:prstGeom>
-            <a:noFill/>
-            <a:ln>
-              <a:noFill/>
-            </a:ln>
-          </p:spPr>
-          <p:txBody>
-            <a:bodyPr wrap="none" lIns="0" tIns="0" rIns="0" bIns="0" anchor="t" anchorCtr="0">
-              <a:spAutoFit/>
-            </a:bodyPr>
-            <a:lstStyle/>
-            <a:p>
-              <a:pPr algn="l"/>
-              <a:r>
-                <a:rPr lang="zh-CN" sz="1050" dirty="0">
-                  <a:solidFill>
-                    <a:srgbClr val="E0E0E0"/>
-                  </a:solidFill>
-                  <a:latin typeface="Consolas"/>
-                  <a:ea typeface="Microsoft YaHei"/>
-                  <a:cs typeface="Consolas"/>
-                </a:rPr>
-                <a:t>        force_sig_fault(SIGSEGV, SEGV_CPERR,</a:t>
-              </a:r>
-            </a:p>
-          </p:txBody>
-        </p:sp>
-        <p:sp>
-          <p:nvSpPr>
-            <p:cNvPr id="21" name="TextBox 21"/>
-            <p:cNvSpPr txBox="1"/>
-            <p:nvPr/>
-          </p:nvSpPr>
-          <p:spPr>
-            <a:xfrm>
-              <a:off x="653415" y="3639502"/>
-              <a:ext cx="1215152" cy="213360"/>
-            </a:xfrm>
-            <a:prstGeom prst="rect">
-              <a:avLst/>
-            </a:prstGeom>
-            <a:noFill/>
-            <a:ln>
-              <a:noFill/>
-            </a:ln>
-          </p:spPr>
-          <p:txBody>
-            <a:bodyPr wrap="none" lIns="0" tIns="0" rIns="0" bIns="0" anchor="t" anchorCtr="0">
-              <a:spAutoFit/>
-            </a:bodyPr>
-            <a:lstStyle/>
-            <a:p>
-              <a:pPr algn="l"/>
-              <a:r>
-                <a:rPr lang="zh-CN" sz="1050" dirty="0">
-                  <a:solidFill>
-                    <a:srgbClr val="E0E0E0"/>
-                  </a:solidFill>
-                  <a:latin typeface="Consolas"/>
-                  <a:ea typeface="Microsoft YaHei"/>
-                  <a:cs typeface="Consolas"/>
-                </a:rPr>
-                <a:t>                        (</a:t>
-              </a:r>
-            </a:p>
-          </p:txBody>
-        </p:sp>
-        <p:sp>
-          <p:nvSpPr>
-            <p:cNvPr id="22" name="TextBox 22"/>
-            <p:cNvSpPr txBox="1"/>
-            <p:nvPr/>
-          </p:nvSpPr>
-          <p:spPr>
-            <a:xfrm>
-              <a:off x="2310765" y="3639502"/>
-              <a:ext cx="325707" cy="213360"/>
-            </a:xfrm>
-            <a:prstGeom prst="rect">
-              <a:avLst/>
-            </a:prstGeom>
-            <a:noFill/>
-            <a:ln>
-              <a:noFill/>
-            </a:ln>
-          </p:spPr>
-          <p:txBody>
-            <a:bodyPr wrap="none" lIns="0" tIns="0" rIns="0" bIns="0" anchor="t" anchorCtr="0">
-              <a:spAutoFit/>
-            </a:bodyPr>
-            <a:lstStyle/>
-            <a:p>
-              <a:pPr algn="l"/>
-              <a:r>
-                <a:rPr lang="zh-CN" sz="1050" dirty="0">
-                  <a:solidFill>
-                    <a:srgbClr val="0AB36E"/>
-                  </a:solidFill>
-                  <a:latin typeface="Consolas"/>
-                  <a:ea typeface="Microsoft YaHei"/>
-                  <a:cs typeface="Consolas"/>
-                </a:rPr>
-                <a:t>void</a:t>
-              </a:r>
-            </a:p>
-          </p:txBody>
-        </p:sp>
-        <p:sp>
-          <p:nvSpPr>
-            <p:cNvPr id="23" name="TextBox 23"/>
-            <p:cNvSpPr txBox="1"/>
-            <p:nvPr/>
-          </p:nvSpPr>
-          <p:spPr>
-            <a:xfrm>
-              <a:off x="2653665" y="3639502"/>
-              <a:ext cx="1552527" cy="213360"/>
-            </a:xfrm>
-            <a:prstGeom prst="rect">
-              <a:avLst/>
-            </a:prstGeom>
-            <a:noFill/>
-            <a:ln>
-              <a:noFill/>
-            </a:ln>
-          </p:spPr>
-          <p:txBody>
-            <a:bodyPr wrap="none" lIns="0" tIns="0" rIns="0" bIns="0" anchor="t" anchorCtr="0">
-              <a:spAutoFit/>
-            </a:bodyPr>
-            <a:lstStyle/>
-            <a:p>
-              <a:pPr algn="l"/>
-              <a:r>
-                <a:rPr lang="zh-CN" sz="1050" dirty="0">
-                  <a:solidFill>
-                    <a:srgbClr val="E0E0E0"/>
-                  </a:solidFill>
-                  <a:latin typeface="Consolas"/>
-                  <a:ea typeface="Microsoft YaHei"/>
-                  <a:cs typeface="Consolas"/>
-                </a:rPr>
-                <a:t>__user *)regs-&gt;ip);</a:t>
-              </a:r>
-            </a:p>
-          </p:txBody>
-        </p:sp>
-        <p:sp>
-          <p:nvSpPr>
-            <p:cNvPr id="24" name="TextBox 24"/>
-            <p:cNvSpPr txBox="1"/>
-            <p:nvPr/>
-          </p:nvSpPr>
-          <p:spPr>
-            <a:xfrm>
-              <a:off x="1320165" y="3858578"/>
-              <a:ext cx="532733" cy="213360"/>
-            </a:xfrm>
-            <a:prstGeom prst="rect">
-              <a:avLst/>
-            </a:prstGeom>
-            <a:noFill/>
-            <a:ln>
-              <a:noFill/>
-            </a:ln>
-          </p:spPr>
-          <p:txBody>
-            <a:bodyPr wrap="none" lIns="0" tIns="0" rIns="0" bIns="0" anchor="t" anchorCtr="0">
-              <a:spAutoFit/>
-            </a:bodyPr>
-            <a:lstStyle/>
-            <a:p>
-              <a:pPr algn="l"/>
-              <a:r>
-                <a:rPr lang="zh-CN" sz="1050" dirty="0">
-                  <a:solidFill>
-                    <a:srgbClr val="0AB36E"/>
-                  </a:solidFill>
-                  <a:latin typeface="Consolas"/>
-                  <a:ea typeface="Microsoft YaHei"/>
-                  <a:cs typeface="Consolas"/>
-                </a:rPr>
-                <a:t>return</a:t>
-              </a:r>
-            </a:p>
-          </p:txBody>
-        </p:sp>
-        <p:sp>
-          <p:nvSpPr>
-            <p:cNvPr id="25" name="TextBox 25"/>
-            <p:cNvSpPr txBox="1"/>
-            <p:nvPr/>
-          </p:nvSpPr>
-          <p:spPr>
-            <a:xfrm>
-              <a:off x="1824990" y="3858578"/>
-              <a:ext cx="111014" cy="213360"/>
-            </a:xfrm>
-            <a:prstGeom prst="rect">
-              <a:avLst/>
-            </a:prstGeom>
-            <a:noFill/>
-            <a:ln>
-              <a:noFill/>
-            </a:ln>
-          </p:spPr>
-          <p:txBody>
-            <a:bodyPr wrap="none" lIns="0" tIns="0" rIns="0" bIns="0" anchor="t" anchorCtr="0">
-              <a:spAutoFit/>
-            </a:bodyPr>
-            <a:lstStyle/>
-            <a:p>
-              <a:pPr algn="l"/>
-              <a:r>
-                <a:rPr lang="zh-CN" sz="1050" dirty="0">
-                  <a:solidFill>
-                    <a:srgbClr val="E0E0E0"/>
-                  </a:solidFill>
-                  <a:latin typeface="Consolas"/>
-                  <a:ea typeface="Microsoft YaHei"/>
-                  <a:cs typeface="Consolas"/>
-                </a:rPr>
-                <a:t>;</a:t>
-              </a:r>
-            </a:p>
-          </p:txBody>
-        </p:sp>
-        <p:sp>
-          <p:nvSpPr>
-            <p:cNvPr id="26" name="TextBox 26"/>
-            <p:cNvSpPr txBox="1"/>
-            <p:nvPr/>
-          </p:nvSpPr>
-          <p:spPr>
-            <a:xfrm>
-              <a:off x="653415" y="4077652"/>
-              <a:ext cx="295037" cy="213360"/>
-            </a:xfrm>
-            <a:prstGeom prst="rect">
-              <a:avLst/>
-            </a:prstGeom>
-            <a:noFill/>
-            <a:ln>
-              <a:noFill/>
-            </a:ln>
-          </p:spPr>
-          <p:txBody>
-            <a:bodyPr wrap="none" lIns="0" tIns="0" rIns="0" bIns="0" anchor="t" anchorCtr="0">
-              <a:spAutoFit/>
-            </a:bodyPr>
-            <a:lstStyle/>
-            <a:p>
-              <a:pPr algn="l"/>
-              <a:r>
-                <a:rPr lang="zh-CN" sz="1050" dirty="0">
-                  <a:solidFill>
-                    <a:srgbClr val="E0E0E0"/>
-                  </a:solidFill>
-                  <a:latin typeface="Consolas"/>
-                  <a:ea typeface="Microsoft YaHei"/>
-                  <a:cs typeface="Consolas"/>
-                </a:rPr>
-                <a:t>    }</a:t>
-              </a:r>
-            </a:p>
-          </p:txBody>
-        </p:sp>
-        <p:sp>
-          <p:nvSpPr>
-            <p:cNvPr id="27" name="TextBox 27"/>
-            <p:cNvSpPr txBox="1"/>
-            <p:nvPr/>
-          </p:nvSpPr>
-          <p:spPr>
-            <a:xfrm>
-              <a:off x="1062990" y="4363402"/>
-              <a:ext cx="1805559" cy="213360"/>
-            </a:xfrm>
-            <a:prstGeom prst="rect">
-              <a:avLst/>
-            </a:prstGeom>
-            <a:noFill/>
-            <a:ln>
-              <a:noFill/>
-            </a:ln>
-          </p:spPr>
-          <p:txBody>
-            <a:bodyPr wrap="none" lIns="0" tIns="0" rIns="0" bIns="0" anchor="t" anchorCtr="0">
-              <a:spAutoFit/>
-            </a:bodyPr>
-            <a:lstStyle/>
-            <a:p>
-              <a:pPr algn="l"/>
-              <a:r>
-                <a:rPr lang="zh-CN" sz="1050" dirty="0">
-                  <a:solidFill>
-                    <a:srgbClr val="6A9955"/>
-                  </a:solidFill>
-                  <a:latin typeface="Consolas"/>
-                  <a:ea typeface="Microsoft YaHei"/>
-                  <a:cs typeface="Consolas"/>
-                </a:rPr>
-                <a:t>/* kernel-mode fault */</a:t>
-              </a:r>
-            </a:p>
-          </p:txBody>
-        </p:sp>
-        <p:sp>
-          <p:nvSpPr>
-            <p:cNvPr id="28" name="TextBox 28"/>
-            <p:cNvSpPr txBox="1"/>
-            <p:nvPr/>
-          </p:nvSpPr>
-          <p:spPr>
-            <a:xfrm>
-              <a:off x="653415" y="4582478"/>
-              <a:ext cx="2418969" cy="213360"/>
-            </a:xfrm>
-            <a:prstGeom prst="rect">
-              <a:avLst/>
-            </a:prstGeom>
-            <a:noFill/>
-            <a:ln>
-              <a:noFill/>
-            </a:ln>
-          </p:spPr>
-          <p:txBody>
-            <a:bodyPr wrap="none" lIns="0" tIns="0" rIns="0" bIns="0" anchor="t" anchorCtr="0">
-              <a:spAutoFit/>
-            </a:bodyPr>
-            <a:lstStyle/>
-            <a:p>
-              <a:pPr algn="l"/>
-              <a:r>
-                <a:rPr lang="zh-CN" sz="1050" dirty="0">
-                  <a:solidFill>
-                    <a:srgbClr val="E0E0E0"/>
-                  </a:solidFill>
-                  <a:latin typeface="Consolas"/>
-                  <a:ea typeface="Microsoft YaHei"/>
-                  <a:cs typeface="Consolas"/>
-                </a:rPr>
-                <a:t>    ibt_fatal = !sysctl_ibt_warn;</a:t>
-              </a:r>
-            </a:p>
-          </p:txBody>
-        </p:sp>
-        <p:sp>
-          <p:nvSpPr>
-            <p:cNvPr id="29" name="TextBox 29"/>
-            <p:cNvSpPr txBox="1"/>
-            <p:nvPr/>
-          </p:nvSpPr>
-          <p:spPr>
-            <a:xfrm>
-              <a:off x="653415" y="4582478"/>
-              <a:ext cx="2418969" cy="213360"/>
-            </a:xfrm>
-            <a:prstGeom prst="rect">
-              <a:avLst/>
-            </a:prstGeom>
-            <a:noFill/>
-            <a:ln>
-              <a:noFill/>
-            </a:ln>
-          </p:spPr>
-          <p:txBody>
-            <a:bodyPr wrap="none" lIns="0" tIns="0" rIns="0" bIns="0" anchor="t" anchorCtr="0">
-              <a:spAutoFit/>
-            </a:bodyPr>
-            <a:lstStyle/>
-            <a:p>
-              <a:pPr algn="l"/>
-              <a:r>
-                <a:rPr lang="zh-CN" sz="1050" dirty="0">
-                  <a:solidFill>
-                    <a:srgbClr val="E0E0E0"/>
-                  </a:solidFill>
-                  <a:latin typeface="Consolas"/>
-                  <a:ea typeface="Microsoft YaHei"/>
-                  <a:cs typeface="Consolas"/>
-                </a:rPr>
-                <a:t>    ibt_fatal = !sysctl_ibt_warn;</a:t>
-              </a:r>
-            </a:p>
-          </p:txBody>
-        </p:sp>
-        <p:sp>
-          <p:nvSpPr>
-            <p:cNvPr id="30" name="TextBox 30"/>
-            <p:cNvSpPr txBox="1"/>
-            <p:nvPr/>
-          </p:nvSpPr>
-          <p:spPr>
-            <a:xfrm>
-              <a:off x="7700010" y="1442085"/>
-              <a:ext cx="1309440" cy="243840"/>
-            </a:xfrm>
-            <a:prstGeom prst="rect">
-              <a:avLst/>
-            </a:prstGeom>
-            <a:noFill/>
-            <a:ln>
-              <a:noFill/>
-            </a:ln>
-          </p:spPr>
-          <p:txBody>
-            <a:bodyPr wrap="none" lIns="0" tIns="0" rIns="0" bIns="0" anchor="t" anchorCtr="0">
-              <a:spAutoFit/>
-            </a:bodyPr>
-            <a:lstStyle/>
-            <a:p>
-              <a:pPr algn="l"/>
-              <a:r>
-                <a:rPr lang="zh-CN" sz="1200" b="1" dirty="0">
-                  <a:solidFill>
-                    <a:srgbClr val="333333"/>
-                  </a:solidFill>
-                  <a:latin typeface="Arial"/>
-                  <a:ea typeface="Microsoft YaHei"/>
-                  <a:cs typeface="Arial"/>
-                </a:rPr>
-                <a:t>Dispatch Logic</a:t>
-              </a:r>
-            </a:p>
-          </p:txBody>
-        </p:sp>
-        <p:sp>
-          <p:nvSpPr>
-            <p:cNvPr id="31" name="Rectangle 31"/>
-            <p:cNvSpPr/>
-            <p:nvPr/>
-          </p:nvSpPr>
-          <p:spPr>
-            <a:xfrm>
-              <a:off x="7620000" y="1762125"/>
-              <a:ext cx="4095750" cy="857250"/>
-            </a:xfrm>
-            <a:prstGeom prst="roundRect">
-              <a:avLst>
-                <a:gd name="adj" fmla="val 8889"/>
-              </a:avLst>
-            </a:prstGeom>
-            <a:solidFill>
-              <a:srgbClr val="FEF2F2"/>
-            </a:solidFill>
-            <a:ln w="14288">
-              <a:solidFill>
-                <a:srgbClr val="EF4444"/>
-              </a:solidFill>
-            </a:ln>
-          </p:spPr>
-        </p:sp>
-        <p:grpSp>
-          <p:nvGrpSpPr>
-            <p:cNvPr id="34" name="Group 34"/>
-            <p:cNvGrpSpPr/>
-            <p:nvPr/>
-          </p:nvGrpSpPr>
-          <p:grpSpPr>
-            <a:xfrm>
-              <a:off x="7820025" y="1933575"/>
-              <a:ext cx="114300" cy="171450"/>
-              <a:chOff x="7820025" y="1933575"/>
-              <a:chExt cx="114300" cy="171450"/>
-            </a:xfrm>
-          </p:grpSpPr>
-          <p:sp>
-            <p:nvSpPr>
-              <p:cNvPr id="32" name="Freeform 32"/>
-              <p:cNvSpPr/>
-              <p:nvPr/>
-            </p:nvSpPr>
-            <p:spPr>
-              <a:xfrm>
-                <a:off x="7839075" y="1933575"/>
-                <a:ext cx="76200" cy="76200"/>
-              </a:xfrm>
-              <a:custGeom>
-                <a:avLst/>
-                <a:gdLst/>
-                <a:ahLst/>
-                <a:cxnLst/>
-                <a:rect l="l" t="t" r="r" b="b"/>
-                <a:pathLst>
-                  <a:path w="76200" h="76200">
-                    <a:moveTo>
-                      <a:pt x="0" y="38100"/>
-                    </a:moveTo>
-                    <a:cubicBezTo>
-                      <a:pt x="0" y="59142"/>
-                      <a:pt x="17058" y="76200"/>
-                      <a:pt x="38100" y="76200"/>
-                    </a:cubicBezTo>
-                    <a:cubicBezTo>
-                      <a:pt x="59142" y="76200"/>
-                      <a:pt x="76200" y="59142"/>
-                      <a:pt x="76200" y="38100"/>
-                    </a:cubicBezTo>
-                    <a:cubicBezTo>
-                      <a:pt x="76200" y="17058"/>
-                      <a:pt x="59142" y="0"/>
-                      <a:pt x="38100" y="0"/>
-                    </a:cubicBezTo>
-                    <a:cubicBezTo>
-                      <a:pt x="17058" y="0"/>
-                      <a:pt x="0" y="17058"/>
-                      <a:pt x="0" y="38100"/>
-                    </a:cubicBezTo>
-                  </a:path>
-                </a:pathLst>
-              </a:custGeom>
-              <a:noFill/>
-              <a:ln w="19050">
-                <a:solidFill>
-                  <a:srgbClr val="EF4444"/>
-                </a:solidFill>
-              </a:ln>
-            </p:spPr>
-          </p:sp>
-          <p:sp>
-            <p:nvSpPr>
-              <p:cNvPr id="33" name="Freeform 33"/>
-              <p:cNvSpPr/>
-              <p:nvPr/>
-            </p:nvSpPr>
-            <p:spPr>
-              <a:xfrm>
-                <a:off x="7820025" y="2047875"/>
-                <a:ext cx="114300" cy="57150"/>
-              </a:xfrm>
-              <a:custGeom>
-                <a:avLst/>
-                <a:gdLst/>
-                <a:ahLst/>
-                <a:cxnLst/>
-                <a:rect l="l" t="t" r="r" b="b"/>
-                <a:pathLst>
-                  <a:path w="114300" h="57150">
-                    <a:moveTo>
-                      <a:pt x="0" y="57150"/>
-                    </a:moveTo>
-                    <a:lnTo>
-                      <a:pt x="0" y="38100"/>
-                    </a:lnTo>
-                    <a:cubicBezTo>
-                      <a:pt x="0" y="17058"/>
-                      <a:pt x="17058" y="0"/>
-                      <a:pt x="38100" y="0"/>
-                    </a:cubicBezTo>
-                    <a:lnTo>
-                      <a:pt x="76200" y="0"/>
-                    </a:lnTo>
-                    <a:cubicBezTo>
-                      <a:pt x="97242" y="0"/>
-                      <a:pt x="114300" y="17058"/>
-                      <a:pt x="114300" y="38100"/>
-                    </a:cubicBezTo>
-                    <a:lnTo>
-                      <a:pt x="114300" y="57150"/>
-                    </a:lnTo>
-                  </a:path>
-                </a:pathLst>
-              </a:custGeom>
-              <a:noFill/>
-              <a:ln w="19050">
-                <a:solidFill>
-                  <a:srgbClr val="EF4444"/>
-                </a:solidFill>
-              </a:ln>
-            </p:spPr>
-          </p:sp>
-        </p:grpSp>
-        <p:sp>
-          <p:nvSpPr>
-            <p:cNvPr id="35" name="TextBox 35"/>
-            <p:cNvSpPr txBox="1"/>
-            <p:nvPr/>
-          </p:nvSpPr>
-          <p:spPr>
-            <a:xfrm>
-              <a:off x="8062912" y="1935956"/>
-              <a:ext cx="1253478" cy="228600"/>
-            </a:xfrm>
-            <a:prstGeom prst="rect">
-              <a:avLst/>
-            </a:prstGeom>
-            <a:noFill/>
-            <a:ln>
-              <a:noFill/>
-            </a:ln>
-          </p:spPr>
-          <p:txBody>
-            <a:bodyPr wrap="none" lIns="0" tIns="0" rIns="0" bIns="0" anchor="t" anchorCtr="0">
-              <a:spAutoFit/>
-            </a:bodyPr>
-            <a:lstStyle/>
-            <a:p>
-              <a:pPr algn="l"/>
-              <a:r>
-                <a:rPr lang="zh-CN" sz="1125" b="1" dirty="0">
-                  <a:solidFill>
-                    <a:srgbClr val="EF4444"/>
-                  </a:solidFill>
-                  <a:latin typeface="Arial"/>
-                  <a:ea typeface="Microsoft YaHei"/>
-                  <a:cs typeface="Arial"/>
-                </a:rPr>
-                <a:t>User-mode #CP</a:t>
-              </a:r>
-            </a:p>
-          </p:txBody>
-        </p:sp>
-        <p:sp>
-          <p:nvSpPr>
-            <p:cNvPr id="36" name="TextBox 36"/>
-            <p:cNvSpPr txBox="1"/>
-            <p:nvPr/>
-          </p:nvSpPr>
-          <p:spPr>
-            <a:xfrm>
-              <a:off x="7797165" y="2191702"/>
-              <a:ext cx="3040047" cy="213360"/>
-            </a:xfrm>
-            <a:prstGeom prst="rect">
-              <a:avLst/>
-            </a:prstGeom>
-            <a:noFill/>
-            <a:ln>
-              <a:noFill/>
-            </a:ln>
-          </p:spPr>
-          <p:txBody>
-            <a:bodyPr wrap="none" lIns="0" tIns="0" rIns="0" bIns="0" anchor="t" anchorCtr="0">
-              <a:spAutoFit/>
-            </a:bodyPr>
-            <a:lstStyle/>
-            <a:p>
-              <a:pPr algn="l"/>
-              <a:r>
-                <a:rPr lang="zh-CN" sz="1050" dirty="0">
-                  <a:solidFill>
-                    <a:srgbClr val="333333"/>
-                  </a:solidFill>
-                  <a:latin typeface="Arial"/>
-                  <a:ea typeface="Microsoft YaHei"/>
-                  <a:cs typeface="Arial"/>
-                </a:rPr>
-                <a:t>Sends SIGSEGV with si_code = SEGV_CPERR</a:t>
-              </a:r>
-            </a:p>
-          </p:txBody>
-        </p:sp>
-        <p:sp>
-          <p:nvSpPr>
-            <p:cNvPr id="37" name="TextBox 37"/>
-            <p:cNvSpPr txBox="1"/>
-            <p:nvPr/>
-          </p:nvSpPr>
-          <p:spPr>
-            <a:xfrm>
-              <a:off x="7798118" y="2399824"/>
-              <a:ext cx="3221617" cy="198120"/>
-            </a:xfrm>
-            <a:prstGeom prst="rect">
-              <a:avLst/>
-            </a:prstGeom>
-            <a:noFill/>
-            <a:ln>
-              <a:noFill/>
-            </a:ln>
-          </p:spPr>
-          <p:txBody>
-            <a:bodyPr wrap="none" lIns="0" tIns="0" rIns="0" bIns="0" anchor="t" anchorCtr="0">
-              <a:spAutoFit/>
-            </a:bodyPr>
-            <a:lstStyle/>
-            <a:p>
-              <a:pPr algn="l"/>
-              <a:r>
-                <a:rPr lang="zh-CN" sz="975" dirty="0">
-                  <a:solidFill>
-                    <a:srgbClr val="555555"/>
-                  </a:solidFill>
-                  <a:latin typeface="Arial"/>
-                  <a:ea typeface="Microsoft YaHei"/>
-                  <a:cs typeface="Arial"/>
-                </a:rPr>
-                <a:t>Process terminated — standard signal handling</a:t>
-              </a:r>
-            </a:p>
-          </p:txBody>
-        </p:sp>
-        <p:sp>
-          <p:nvSpPr>
-            <p:cNvPr id="38" name="Rectangle 38"/>
-            <p:cNvSpPr/>
-            <p:nvPr/>
-          </p:nvSpPr>
-          <p:spPr>
-            <a:xfrm>
-              <a:off x="7620000" y="2762250"/>
-              <a:ext cx="4095750" cy="1000125"/>
-            </a:xfrm>
-            <a:prstGeom prst="roundRect">
-              <a:avLst>
-                <a:gd name="adj" fmla="val 7619"/>
-              </a:avLst>
-            </a:prstGeom>
-            <a:solidFill>
-              <a:srgbClr val="FFF7ED"/>
-            </a:solidFill>
-            <a:ln w="14288">
-              <a:solidFill>
-                <a:srgbClr val="F79646"/>
-              </a:solidFill>
-            </a:ln>
-          </p:spPr>
-        </p:sp>
-        <p:grpSp>
-          <p:nvGrpSpPr>
-            <p:cNvPr id="49" name="Group 49"/>
-            <p:cNvGrpSpPr/>
-            <p:nvPr/>
-          </p:nvGrpSpPr>
-          <p:grpSpPr>
-            <a:xfrm>
-              <a:off x="7791450" y="2933700"/>
-              <a:ext cx="171450" cy="171450"/>
-              <a:chOff x="7791450" y="2933700"/>
-              <a:chExt cx="171450" cy="171450"/>
-            </a:xfrm>
-          </p:grpSpPr>
-          <p:sp>
-            <p:nvSpPr>
-              <p:cNvPr id="39" name="Freeform 39"/>
-              <p:cNvSpPr/>
-              <p:nvPr/>
-            </p:nvSpPr>
-            <p:spPr>
-              <a:xfrm>
-                <a:off x="7810500" y="2952750"/>
-                <a:ext cx="133350" cy="133350"/>
-              </a:xfrm>
-              <a:custGeom>
-                <a:avLst/>
-                <a:gdLst/>
-                <a:ahLst/>
-                <a:cxnLst/>
-                <a:rect l="l" t="t" r="r" b="b"/>
-                <a:pathLst>
-                  <a:path w="133350" h="133350">
-                    <a:moveTo>
-                      <a:pt x="0" y="9525"/>
-                    </a:moveTo>
-                    <a:cubicBezTo>
-                      <a:pt x="0" y="4264"/>
-                      <a:pt x="4264" y="0"/>
-                      <a:pt x="9525" y="0"/>
-                    </a:cubicBezTo>
-                    <a:lnTo>
-                      <a:pt x="123825" y="0"/>
-                    </a:lnTo>
-                    <a:cubicBezTo>
-                      <a:pt x="129086" y="0"/>
-                      <a:pt x="133350" y="4264"/>
-                      <a:pt x="133350" y="9525"/>
-                    </a:cubicBezTo>
-                    <a:lnTo>
-                      <a:pt x="133350" y="123825"/>
-                    </a:lnTo>
-                    <a:cubicBezTo>
-                      <a:pt x="133350" y="129086"/>
-                      <a:pt x="129086" y="133350"/>
-                      <a:pt x="123825" y="133350"/>
-                    </a:cubicBezTo>
-                    <a:lnTo>
-                      <a:pt x="9525" y="133350"/>
-                    </a:lnTo>
-                    <a:cubicBezTo>
-                      <a:pt x="4264" y="133350"/>
-                      <a:pt x="0" y="129086"/>
-                      <a:pt x="0" y="123825"/>
-                    </a:cubicBezTo>
-                    <a:lnTo>
-                      <a:pt x="0" y="9525"/>
-                    </a:lnTo>
-                  </a:path>
-                </a:pathLst>
-              </a:custGeom>
-              <a:noFill/>
-              <a:ln w="19050">
-                <a:solidFill>
-                  <a:srgbClr val="F79646"/>
-                </a:solidFill>
-              </a:ln>
-            </p:spPr>
-          </p:sp>
-          <p:sp>
-            <p:nvSpPr>
-              <p:cNvPr id="40" name="Freeform 40"/>
-              <p:cNvSpPr/>
-              <p:nvPr/>
-            </p:nvSpPr>
-            <p:spPr>
-              <a:xfrm>
-                <a:off x="7848600" y="2990850"/>
-                <a:ext cx="57150" cy="57150"/>
-              </a:xfrm>
-              <a:custGeom>
-                <a:avLst/>
-                <a:gdLst/>
-                <a:ahLst/>
-                <a:cxnLst/>
-                <a:rect l="l" t="t" r="r" b="b"/>
-                <a:pathLst>
-                  <a:path w="57150" h="57150">
-                    <a:moveTo>
-                      <a:pt x="0" y="0"/>
-                    </a:moveTo>
-                    <a:lnTo>
-                      <a:pt x="57150" y="0"/>
-                    </a:lnTo>
-                    <a:lnTo>
-                      <a:pt x="57150" y="57150"/>
-                    </a:lnTo>
-                    <a:lnTo>
-                      <a:pt x="0" y="57150"/>
-                    </a:lnTo>
-                    <a:lnTo>
-                      <a:pt x="0" y="0"/>
-                    </a:lnTo>
-                  </a:path>
-                </a:pathLst>
-              </a:custGeom>
-              <a:noFill/>
-              <a:ln w="19050">
-                <a:solidFill>
-                  <a:srgbClr val="F79646"/>
-                </a:solidFill>
-              </a:ln>
-            </p:spPr>
-          </p:sp>
-          <p:sp>
-            <p:nvSpPr>
-              <p:cNvPr id="41" name="Freeform 41"/>
-              <p:cNvSpPr/>
-              <p:nvPr/>
-            </p:nvSpPr>
-            <p:spPr>
-              <a:xfrm>
-                <a:off x="7791450" y="3000375"/>
-                <a:ext cx="19050" cy="9525"/>
-              </a:xfrm>
-              <a:custGeom>
-                <a:avLst/>
-                <a:gdLst/>
-                <a:ahLst/>
-                <a:cxnLst/>
-                <a:rect l="l" t="t" r="r" b="b"/>
-                <a:pathLst>
-                  <a:path w="19050" h="9525">
-                    <a:moveTo>
-                      <a:pt x="0" y="0"/>
-                    </a:moveTo>
-                    <a:lnTo>
-                      <a:pt x="19050" y="0"/>
-                    </a:lnTo>
-                  </a:path>
-                </a:pathLst>
-              </a:custGeom>
-              <a:noFill/>
-              <a:ln w="19050">
-                <a:solidFill>
-                  <a:srgbClr val="F79646"/>
-                </a:solidFill>
-              </a:ln>
-            </p:spPr>
-          </p:sp>
-          <p:sp>
-            <p:nvSpPr>
-              <p:cNvPr id="42" name="Freeform 42"/>
-              <p:cNvSpPr/>
-              <p:nvPr/>
-            </p:nvSpPr>
-            <p:spPr>
-              <a:xfrm>
-                <a:off x="7791450" y="3038475"/>
-                <a:ext cx="19050" cy="9525"/>
-              </a:xfrm>
-              <a:custGeom>
-                <a:avLst/>
-                <a:gdLst/>
-                <a:ahLst/>
-                <a:cxnLst/>
-                <a:rect l="l" t="t" r="r" b="b"/>
-                <a:pathLst>
-                  <a:path w="19050" h="9525">
-                    <a:moveTo>
-                      <a:pt x="0" y="0"/>
-                    </a:moveTo>
-                    <a:lnTo>
-                      <a:pt x="19050" y="0"/>
-                    </a:lnTo>
-                  </a:path>
-                </a:pathLst>
-              </a:custGeom>
-              <a:noFill/>
-              <a:ln w="19050">
-                <a:solidFill>
-                  <a:srgbClr val="F79646"/>
-                </a:solidFill>
-              </a:ln>
-            </p:spPr>
-          </p:sp>
-          <p:sp>
-            <p:nvSpPr>
-              <p:cNvPr id="43" name="Freeform 43"/>
-              <p:cNvSpPr/>
-              <p:nvPr/>
-            </p:nvSpPr>
-            <p:spPr>
-              <a:xfrm>
-                <a:off x="7858125" y="2933700"/>
-                <a:ext cx="9525" cy="19050"/>
-              </a:xfrm>
-              <a:custGeom>
-                <a:avLst/>
-                <a:gdLst/>
-                <a:ahLst/>
-                <a:cxnLst/>
-                <a:rect l="l" t="t" r="r" b="b"/>
-                <a:pathLst>
-                  <a:path w="9525" h="19050">
-                    <a:moveTo>
-                      <a:pt x="0" y="0"/>
-                    </a:moveTo>
-                    <a:lnTo>
-                      <a:pt x="0" y="19050"/>
-                    </a:lnTo>
-                  </a:path>
-                </a:pathLst>
-              </a:custGeom>
-              <a:noFill/>
-              <a:ln w="19050">
-                <a:solidFill>
-                  <a:srgbClr val="F79646"/>
-                </a:solidFill>
-              </a:ln>
-            </p:spPr>
-          </p:sp>
-          <p:sp>
-            <p:nvSpPr>
-              <p:cNvPr id="44" name="Freeform 44"/>
-              <p:cNvSpPr/>
-              <p:nvPr/>
-            </p:nvSpPr>
-            <p:spPr>
-              <a:xfrm>
-                <a:off x="7896225" y="2933700"/>
-                <a:ext cx="9525" cy="19050"/>
-              </a:xfrm>
-              <a:custGeom>
-                <a:avLst/>
-                <a:gdLst/>
-                <a:ahLst/>
-                <a:cxnLst/>
-                <a:rect l="l" t="t" r="r" b="b"/>
-                <a:pathLst>
-                  <a:path w="9525" h="19050">
-                    <a:moveTo>
-                      <a:pt x="0" y="0"/>
-                    </a:moveTo>
-                    <a:lnTo>
-                      <a:pt x="0" y="19050"/>
-                    </a:lnTo>
-                  </a:path>
-                </a:pathLst>
-              </a:custGeom>
-              <a:noFill/>
-              <a:ln w="19050">
-                <a:solidFill>
-                  <a:srgbClr val="F79646"/>
-                </a:solidFill>
-              </a:ln>
-            </p:spPr>
-          </p:sp>
-          <p:sp>
-            <p:nvSpPr>
-              <p:cNvPr id="45" name="Freeform 45"/>
-              <p:cNvSpPr/>
-              <p:nvPr/>
-            </p:nvSpPr>
-            <p:spPr>
-              <a:xfrm>
-                <a:off x="7943850" y="3000375"/>
-                <a:ext cx="19050" cy="9525"/>
-              </a:xfrm>
-              <a:custGeom>
-                <a:avLst/>
-                <a:gdLst/>
-                <a:ahLst/>
-                <a:cxnLst/>
-                <a:rect l="l" t="t" r="r" b="b"/>
-                <a:pathLst>
-                  <a:path w="19050" h="9525">
-                    <a:moveTo>
-                      <a:pt x="19050" y="0"/>
-                    </a:moveTo>
-                    <a:lnTo>
-                      <a:pt x="0" y="0"/>
-                    </a:lnTo>
-                  </a:path>
-                </a:pathLst>
-              </a:custGeom>
-              <a:noFill/>
-              <a:ln w="19050">
-                <a:solidFill>
-                  <a:srgbClr val="F79646"/>
-                </a:solidFill>
-              </a:ln>
-            </p:spPr>
-          </p:sp>
-          <p:sp>
-            <p:nvSpPr>
-              <p:cNvPr id="46" name="Freeform 46"/>
-              <p:cNvSpPr/>
-              <p:nvPr/>
-            </p:nvSpPr>
-            <p:spPr>
-              <a:xfrm>
-                <a:off x="7943850" y="3038475"/>
-                <a:ext cx="19050" cy="9525"/>
-              </a:xfrm>
-              <a:custGeom>
-                <a:avLst/>
-                <a:gdLst/>
-                <a:ahLst/>
-                <a:cxnLst/>
-                <a:rect l="l" t="t" r="r" b="b"/>
-                <a:pathLst>
-                  <a:path w="19050" h="9525">
-                    <a:moveTo>
-                      <a:pt x="19050" y="0"/>
-                    </a:moveTo>
-                    <a:lnTo>
-                      <a:pt x="0" y="0"/>
-                    </a:lnTo>
-                  </a:path>
-                </a:pathLst>
-              </a:custGeom>
-              <a:noFill/>
-              <a:ln w="19050">
-                <a:solidFill>
-                  <a:srgbClr val="F79646"/>
-                </a:solidFill>
-              </a:ln>
-            </p:spPr>
-          </p:sp>
-          <p:sp>
-            <p:nvSpPr>
-              <p:cNvPr id="47" name="Freeform 47"/>
-              <p:cNvSpPr/>
-              <p:nvPr/>
-            </p:nvSpPr>
-            <p:spPr>
-              <a:xfrm>
-                <a:off x="7896225" y="3086100"/>
-                <a:ext cx="9525" cy="19050"/>
-              </a:xfrm>
-              <a:custGeom>
-                <a:avLst/>
-                <a:gdLst/>
-                <a:ahLst/>
-                <a:cxnLst/>
-                <a:rect l="l" t="t" r="r" b="b"/>
-                <a:pathLst>
-                  <a:path w="9525" h="19050">
-                    <a:moveTo>
-                      <a:pt x="0" y="19050"/>
-                    </a:moveTo>
-                    <a:lnTo>
-                      <a:pt x="0" y="0"/>
-                    </a:lnTo>
-                  </a:path>
-                </a:pathLst>
-              </a:custGeom>
-              <a:noFill/>
-              <a:ln w="19050">
-                <a:solidFill>
-                  <a:srgbClr val="F79646"/>
-                </a:solidFill>
-              </a:ln>
-            </p:spPr>
-          </p:sp>
-          <p:sp>
-            <p:nvSpPr>
-              <p:cNvPr id="48" name="Freeform 48"/>
-              <p:cNvSpPr/>
-              <p:nvPr/>
-            </p:nvSpPr>
-            <p:spPr>
-              <a:xfrm>
-                <a:off x="7858125" y="3086100"/>
-                <a:ext cx="9525" cy="19050"/>
-              </a:xfrm>
-              <a:custGeom>
-                <a:avLst/>
-                <a:gdLst/>
-                <a:ahLst/>
-                <a:cxnLst/>
-                <a:rect l="l" t="t" r="r" b="b"/>
-                <a:pathLst>
-                  <a:path w="9525" h="19050">
-                    <a:moveTo>
-                      <a:pt x="0" y="19050"/>
-                    </a:moveTo>
-                    <a:lnTo>
-                      <a:pt x="0" y="0"/>
-                    </a:lnTo>
-                  </a:path>
-                </a:pathLst>
-              </a:custGeom>
-              <a:noFill/>
-              <a:ln w="19050">
-                <a:solidFill>
-                  <a:srgbClr val="F79646"/>
-                </a:solidFill>
-              </a:ln>
-            </p:spPr>
-          </p:sp>
-        </p:grpSp>
-        <p:sp>
-          <p:nvSpPr>
-            <p:cNvPr id="50" name="TextBox 50"/>
-            <p:cNvSpPr txBox="1"/>
-            <p:nvPr/>
-          </p:nvSpPr>
-          <p:spPr>
-            <a:xfrm>
-              <a:off x="8062912" y="2936081"/>
-              <a:ext cx="1400121" cy="228600"/>
-            </a:xfrm>
-            <a:prstGeom prst="rect">
-              <a:avLst/>
-            </a:prstGeom>
-            <a:noFill/>
-            <a:ln>
-              <a:noFill/>
-            </a:ln>
-          </p:spPr>
-          <p:txBody>
-            <a:bodyPr wrap="none" lIns="0" tIns="0" rIns="0" bIns="0" anchor="t" anchorCtr="0">
-              <a:spAutoFit/>
-            </a:bodyPr>
-            <a:lstStyle/>
-            <a:p>
-              <a:pPr algn="l"/>
-              <a:r>
-                <a:rPr lang="zh-CN" sz="1125" b="1" dirty="0">
-                  <a:solidFill>
-                    <a:srgbClr val="F79646"/>
-                  </a:solidFill>
-                  <a:latin typeface="Arial"/>
-                  <a:ea typeface="Microsoft YaHei"/>
-                  <a:cs typeface="Arial"/>
-                </a:rPr>
-                <a:t>Kernel-mode #CP</a:t>
-              </a:r>
-            </a:p>
-          </p:txBody>
-        </p:sp>
-        <p:sp>
-          <p:nvSpPr>
-            <p:cNvPr id="51" name="TextBox 51"/>
-            <p:cNvSpPr txBox="1"/>
-            <p:nvPr/>
-          </p:nvSpPr>
-          <p:spPr>
-            <a:xfrm>
-              <a:off x="7797165" y="3191828"/>
-              <a:ext cx="2503313" cy="213360"/>
-            </a:xfrm>
-            <a:prstGeom prst="rect">
-              <a:avLst/>
-            </a:prstGeom>
-            <a:noFill/>
-            <a:ln>
-              <a:noFill/>
-            </a:ln>
-          </p:spPr>
-          <p:txBody>
-            <a:bodyPr wrap="none" lIns="0" tIns="0" rIns="0" bIns="0" anchor="t" anchorCtr="0">
-              <a:spAutoFit/>
-            </a:bodyPr>
-            <a:lstStyle/>
-            <a:p>
-              <a:pPr algn="l"/>
-              <a:r>
-                <a:rPr lang="zh-CN" sz="1050" dirty="0">
-                  <a:solidFill>
-                    <a:srgbClr val="333333"/>
-                  </a:solidFill>
-                  <a:latin typeface="Arial"/>
-                  <a:ea typeface="Microsoft YaHei"/>
-                  <a:cs typeface="Arial"/>
-                </a:rPr>
-                <a:t>Default: BUG() — panic the kernel</a:t>
-              </a:r>
-            </a:p>
-          </p:txBody>
-        </p:sp>
-        <p:sp>
-          <p:nvSpPr>
-            <p:cNvPr id="52" name="TextBox 52"/>
-            <p:cNvSpPr txBox="1"/>
-            <p:nvPr/>
-          </p:nvSpPr>
-          <p:spPr>
-            <a:xfrm>
-              <a:off x="7797165" y="3391852"/>
-              <a:ext cx="2733342" cy="213360"/>
-            </a:xfrm>
-            <a:prstGeom prst="rect">
-              <a:avLst/>
-            </a:prstGeom>
-            <a:noFill/>
-            <a:ln>
-              <a:noFill/>
-            </a:ln>
-          </p:spPr>
-          <p:txBody>
-            <a:bodyPr wrap="none" lIns="0" tIns="0" rIns="0" bIns="0" anchor="t" anchorCtr="0">
-              <a:spAutoFit/>
-            </a:bodyPr>
-            <a:lstStyle/>
-            <a:p>
-              <a:pPr algn="l"/>
-              <a:r>
-                <a:rPr lang="zh-CN" sz="1050" dirty="0">
-                  <a:solidFill>
-                    <a:srgbClr val="333333"/>
-                  </a:solidFill>
-                  <a:latin typeface="Arial"/>
-                  <a:ea typeface="Microsoft YaHei"/>
-                  <a:cs typeface="Arial"/>
-                </a:rPr>
-                <a:t>ibt=warn: WARN() — log and continue</a:t>
-              </a:r>
-            </a:p>
-          </p:txBody>
-        </p:sp>
-        <p:sp>
-          <p:nvSpPr>
-            <p:cNvPr id="53" name="TextBox 53"/>
-            <p:cNvSpPr txBox="1"/>
-            <p:nvPr/>
-          </p:nvSpPr>
-          <p:spPr>
-            <a:xfrm>
-              <a:off x="7798118" y="3599974"/>
-              <a:ext cx="3428095" cy="198120"/>
-            </a:xfrm>
-            <a:prstGeom prst="rect">
-              <a:avLst/>
-            </a:prstGeom>
-            <a:noFill/>
-            <a:ln>
-              <a:noFill/>
-            </a:ln>
-          </p:spPr>
-          <p:txBody>
-            <a:bodyPr wrap="none" lIns="0" tIns="0" rIns="0" bIns="0" anchor="t" anchorCtr="0">
-              <a:spAutoFit/>
-            </a:bodyPr>
-            <a:lstStyle/>
-            <a:p>
-              <a:pPr algn="l"/>
-              <a:r>
-                <a:rPr lang="zh-CN" sz="975" dirty="0">
-                  <a:solidFill>
-                    <a:srgbClr val="555555"/>
-                  </a:solidFill>
-                  <a:latin typeface="Arial"/>
-                  <a:ea typeface="Microsoft YaHei"/>
-                  <a:cs typeface="Arial"/>
-                </a:rPr>
-                <a:t>Boot param allows permissive mode for debugging</a:t>
-              </a:r>
-            </a:p>
-          </p:txBody>
-        </p:sp>
-        <p:sp>
-          <p:nvSpPr>
-            <p:cNvPr id="54" name="Rectangle 54"/>
-            <p:cNvSpPr/>
-            <p:nvPr/>
-          </p:nvSpPr>
-          <p:spPr>
-            <a:xfrm>
-              <a:off x="7620000" y="3905250"/>
-              <a:ext cx="4095750" cy="666750"/>
-            </a:xfrm>
-            <a:prstGeom prst="roundRect">
-              <a:avLst>
-                <a:gd name="adj" fmla="val 11429"/>
-              </a:avLst>
-            </a:prstGeom>
-            <a:solidFill>
-              <a:srgbClr val="F0FDF9"/>
-            </a:solidFill>
-            <a:ln w="14288">
-              <a:solidFill>
-                <a:srgbClr val="0AB36E"/>
-              </a:solidFill>
-            </a:ln>
-          </p:spPr>
-        </p:sp>
-        <p:sp>
-          <p:nvSpPr>
-            <p:cNvPr id="55" name="Freeform 55"/>
-            <p:cNvSpPr/>
-            <p:nvPr/>
-          </p:nvSpPr>
-          <p:spPr>
-            <a:xfrm>
-              <a:off x="7810500" y="4076700"/>
-              <a:ext cx="133350" cy="171450"/>
-            </a:xfrm>
-            <a:custGeom>
-              <a:avLst/>
-              <a:gdLst/>
-              <a:ahLst/>
-              <a:cxnLst/>
-              <a:rect l="l" t="t" r="r" b="b"/>
-              <a:pathLst>
-                <a:path w="133350" h="171450">
-                  <a:moveTo>
-                    <a:pt x="76200" y="0"/>
-                  </a:moveTo>
-                  <a:lnTo>
-                    <a:pt x="76200" y="66675"/>
-                  </a:lnTo>
-                  <a:lnTo>
-                    <a:pt x="133350" y="66675"/>
-                  </a:lnTo>
-                  <a:lnTo>
-                    <a:pt x="57150" y="171450"/>
-                  </a:lnTo>
-                  <a:lnTo>
-                    <a:pt x="57150" y="104775"/>
-                  </a:lnTo>
-                  <a:lnTo>
-                    <a:pt x="0" y="104775"/>
-                  </a:lnTo>
-                  <a:lnTo>
-                    <a:pt x="76200" y="0"/>
-                  </a:lnTo>
-                </a:path>
-              </a:pathLst>
-            </a:custGeom>
-            <a:noFill/>
-            <a:ln w="19050">
-              <a:solidFill>
-                <a:srgbClr val="0AB36E"/>
-              </a:solidFill>
-            </a:ln>
-          </p:spPr>
-        </p:sp>
-        <p:sp>
-          <p:nvSpPr>
-            <p:cNvPr id="56" name="TextBox 56"/>
-            <p:cNvSpPr txBox="1"/>
-            <p:nvPr/>
-          </p:nvSpPr>
-          <p:spPr>
-            <a:xfrm>
-              <a:off x="8062912" y="4079081"/>
-              <a:ext cx="1011948" cy="228600"/>
-            </a:xfrm>
-            <a:prstGeom prst="rect">
-              <a:avLst/>
-            </a:prstGeom>
-            <a:noFill/>
-            <a:ln>
-              <a:noFill/>
-            </a:ln>
-          </p:spPr>
-          <p:txBody>
-            <a:bodyPr wrap="none" lIns="0" tIns="0" rIns="0" bIns="0" anchor="t" anchorCtr="0">
-              <a:spAutoFit/>
-            </a:bodyPr>
-            <a:lstStyle/>
-            <a:p>
-              <a:pPr algn="l"/>
-              <a:r>
-                <a:rPr lang="zh-CN" sz="1125" b="1" dirty="0">
-                  <a:solidFill>
-                    <a:srgbClr val="0AB36E"/>
-                  </a:solidFill>
-                  <a:latin typeface="Arial"/>
-                  <a:ea typeface="Microsoft YaHei"/>
-                  <a:cs typeface="Arial"/>
-                </a:rPr>
-                <a:t>FRED-aware</a:t>
-              </a:r>
-            </a:p>
-          </p:txBody>
-        </p:sp>
-        <p:sp>
-          <p:nvSpPr>
-            <p:cNvPr id="57" name="TextBox 57"/>
-            <p:cNvSpPr txBox="1"/>
-            <p:nvPr/>
-          </p:nvSpPr>
-          <p:spPr>
-            <a:xfrm>
-              <a:off x="7797165" y="4325302"/>
-              <a:ext cx="3699462" cy="213360"/>
-            </a:xfrm>
-            <a:prstGeom prst="rect">
-              <a:avLst/>
-            </a:prstGeom>
-            <a:noFill/>
-            <a:ln>
-              <a:noFill/>
-            </a:ln>
-          </p:spPr>
-          <p:txBody>
-            <a:bodyPr wrap="none" lIns="0" tIns="0" rIns="0" bIns="0" anchor="t" anchorCtr="0">
-              <a:spAutoFit/>
-            </a:bodyPr>
-            <a:lstStyle/>
-            <a:p>
-              <a:pPr algn="l"/>
-              <a:r>
-                <a:rPr lang="zh-CN" sz="1050" dirty="0">
-                  <a:solidFill>
-                    <a:srgbClr val="333333"/>
-                  </a:solidFill>
-                  <a:latin typeface="Arial"/>
-                  <a:ea typeface="Microsoft YaHei"/>
-                  <a:cs typeface="Arial"/>
-                </a:rPr>
-                <a:t>Clears WFE (Wait-For-ENDBRANCH) state on entry</a:t>
-              </a:r>
-            </a:p>
-          </p:txBody>
-        </p:sp>
-        <p:sp>
-          <p:nvSpPr>
-            <p:cNvPr id="58" name="Rectangle 58"/>
-            <p:cNvSpPr/>
-            <p:nvPr/>
-          </p:nvSpPr>
-          <p:spPr>
-            <a:xfrm>
-              <a:off x="476250" y="5000625"/>
-              <a:ext cx="11239500" cy="762000"/>
-            </a:xfrm>
-            <a:prstGeom prst="roundRect">
-              <a:avLst>
-                <a:gd name="adj" fmla="val 10000"/>
-              </a:avLst>
-            </a:prstGeom>
-            <a:solidFill>
-              <a:srgbClr val="1E293B"/>
-            </a:solidFill>
-            <a:ln>
-              <a:noFill/>
-            </a:ln>
-          </p:spPr>
-        </p:sp>
-        <p:sp>
-          <p:nvSpPr>
-            <p:cNvPr id="59" name="TextBox 59"/>
-            <p:cNvSpPr txBox="1"/>
-            <p:nvPr/>
-          </p:nvSpPr>
-          <p:spPr>
-            <a:xfrm>
-              <a:off x="843915" y="5173028"/>
-              <a:ext cx="1733483" cy="213360"/>
-            </a:xfrm>
-            <a:prstGeom prst="rect">
-              <a:avLst/>
-            </a:prstGeom>
-            <a:noFill/>
-            <a:ln>
-              <a:noFill/>
-            </a:ln>
-          </p:spPr>
-          <p:txBody>
-            <a:bodyPr wrap="none" lIns="0" tIns="0" rIns="0" bIns="0" anchor="t" anchorCtr="0">
-              <a:spAutoFit/>
-            </a:bodyPr>
-            <a:lstStyle/>
-            <a:p>
-              <a:pPr algn="l"/>
-              <a:r>
-                <a:rPr lang="zh-CN" sz="1050" b="1" dirty="0">
-                  <a:solidFill>
-                    <a:srgbClr val="0AB36E"/>
-                  </a:solidFill>
-                  <a:latin typeface="Arial"/>
-                  <a:ea typeface="Microsoft YaHei"/>
-                  <a:cs typeface="Arial"/>
-                </a:rPr>
-                <a:t>Handler Flow Summary</a:t>
-              </a:r>
-            </a:p>
-          </p:txBody>
-        </p:sp>
-        <p:sp>
-          <p:nvSpPr>
-            <p:cNvPr id="60" name="TextBox 60"/>
-            <p:cNvSpPr txBox="1"/>
-            <p:nvPr/>
-          </p:nvSpPr>
-          <p:spPr>
-            <a:xfrm>
-              <a:off x="844868" y="5438299"/>
-              <a:ext cx="5542717" cy="198120"/>
-            </a:xfrm>
-            <a:prstGeom prst="rect">
-              <a:avLst/>
-            </a:prstGeom>
-            <a:noFill/>
-            <a:ln>
-              <a:noFill/>
-            </a:ln>
-          </p:spPr>
-          <p:txBody>
-            <a:bodyPr wrap="none" lIns="0" tIns="0" rIns="0" bIns="0" anchor="t" anchorCtr="0">
-              <a:spAutoFit/>
-            </a:bodyPr>
-            <a:lstStyle/>
-            <a:p>
-              <a:pPr algn="l"/>
-              <a:r>
-                <a:rPr lang="zh-CN" sz="975" dirty="0">
-                  <a:solidFill>
-                    <a:srgbClr val="E0E0E0"/>
-                  </a:solidFill>
-                  <a:latin typeface="Consolas"/>
-                  <a:ea typeface="Microsoft YaHei"/>
-                  <a:cs typeface="Consolas"/>
-                </a:rPr>
-                <a:t>#CP trap → check IBT enabled → user_mode? → SIGSEGV : (ibt_warn? → WARN : BUG)</a:t>
-              </a:r>
-            </a:p>
-          </p:txBody>
-        </p:sp>
-        <p:sp>
-          <p:nvSpPr>
-            <p:cNvPr id="61" name="TextBox 61"/>
-            <p:cNvSpPr txBox="1"/>
-            <p:nvPr/>
-          </p:nvSpPr>
-          <p:spPr>
-            <a:xfrm>
-              <a:off x="845820" y="5598795"/>
-              <a:ext cx="5339810" cy="182880"/>
-            </a:xfrm>
-            <a:prstGeom prst="rect">
-              <a:avLst/>
-            </a:prstGeom>
-            <a:noFill/>
-            <a:ln>
-              <a:noFill/>
-            </a:ln>
-          </p:spPr>
-          <p:txBody>
-            <a:bodyPr wrap="none" lIns="0" tIns="0" rIns="0" bIns="0" anchor="t" anchorCtr="0">
-              <a:spAutoFit/>
-            </a:bodyPr>
-            <a:lstStyle/>
-            <a:p>
-              <a:pPr algn="l"/>
-              <a:r>
-                <a:rPr lang="zh-CN" sz="900" dirty="0">
-                  <a:solidFill>
-                    <a:srgbClr val="6A9955"/>
-                  </a:solidFill>
-                  <a:latin typeface="Arial"/>
-                  <a:ea typeface="Microsoft YaHei"/>
-                  <a:cs typeface="Arial"/>
-                </a:rPr>
-                <a:t>FRED (Flexible Return and Event Delivery) automatically manages the tracker state</a:t>
-              </a:r>
-            </a:p>
-          </p:txBody>
-        </p:sp>
-      </p:grpSp>
-      <p:grpSp>
-        <p:nvGrpSpPr>
           <p:cNvPr id="65" name="Group 65"/>
           <p:cNvGrpSpPr/>
           <p:nvPr/>
@@ -44436,6 +41889,36 @@
           </p:txBody>
         </p:sp>
       </p:grpSp>
+      <p:pic>
+        <p:nvPicPr>
+          <p:cNvPr id="298" name="Picture 297">
+            <a:extLst>
+              <a:ext uri="{FF2B5EF4-FFF2-40B4-BE49-F238E27FC236}">
+                <a16:creationId xmlns:a16="http://schemas.microsoft.com/office/drawing/2014/main" id="{1039C27B-79CF-E478-A6D3-1349C74B1411}"/>
+              </a:ext>
+            </a:extLst>
+          </p:cNvPr>
+          <p:cNvPicPr>
+            <a:picLocks noChangeAspect="1"/>
+          </p:cNvPicPr>
+          <p:nvPr/>
+        </p:nvPicPr>
+        <p:blipFill>
+          <a:blip r:embed="rId5"/>
+          <a:stretch>
+            <a:fillRect/>
+          </a:stretch>
+        </p:blipFill>
+        <p:spPr>
+          <a:xfrm>
+            <a:off x="294771" y="1271664"/>
+            <a:ext cx="11147871" cy="4522092"/>
+          </a:xfrm>
+          <a:prstGeom prst="rect">
+            <a:avLst/>
+          </a:prstGeom>
+        </p:spPr>
+      </p:pic>
     </p:spTree>
   </p:cSld>
   <p:clrMapOvr>
@@ -44453,95 +41936,6 @@
       </p:transition>
     </mc:Fallback>
   </mc:AlternateContent>
-  <p:timing>
-    <p:tnLst>
-      <p:par>
-        <p:cTn id="1" dur="indefinite" restart="never" nodeType="tmRoot">
-          <p:childTnLst>
-            <p:seq concurrent="1" nextAc="seek">
-              <p:cTn id="2" dur="indefinite" nodeType="mainSeq">
-                <p:childTnLst>
-                  <p:par>
-                    <p:cTn id="3" fill="hold">
-                      <p:stCondLst>
-                        <p:cond delay="indefinite"/>
-                        <p:cond evt="onBegin" delay="0">
-                          <p:tn val="2"/>
-                        </p:cond>
-                      </p:stCondLst>
-                      <p:childTnLst>
-                        <p:par>
-                          <p:cTn id="4" fill="hold">
-                            <p:stCondLst>
-                              <p:cond delay="0"/>
-                            </p:stCondLst>
-                            <p:childTnLst>
-                              <p:par>
-                                <p:cTn id="5" presetID="10" presetClass="entr" presetSubtype="0" fill="hold" nodeType="afterEffect">
-                                  <p:stCondLst>
-                                    <p:cond delay="0"/>
-                                  </p:stCondLst>
-                                  <p:childTnLst>
-                                    <p:set>
-                                      <p:cBhvr>
-                                        <p:cTn id="6" dur="1" fill="hold">
-                                          <p:stCondLst>
-                                            <p:cond delay="0"/>
-                                          </p:stCondLst>
-                                        </p:cTn>
-                                        <p:tgtEl>
-                                          <p:spTgt spid="62"/>
-                                        </p:tgtEl>
-                                        <p:attrNameLst>
-                                          <p:attrName>style.visibility</p:attrName>
-                                        </p:attrNameLst>
-                                      </p:cBhvr>
-                                      <p:to>
-                                        <p:strVal val="visible"/>
-                                      </p:to>
-                                    </p:set>
-                                    <p:animEffect transition="in" filter="fade">
-                                      <p:cBhvr>
-                                        <p:cTn id="7" dur="400"/>
-                                        <p:tgtEl>
-                                          <p:spTgt spid="62"/>
-                                        </p:tgtEl>
-                                      </p:cBhvr>
-                                    </p:animEffect>
-                                  </p:childTnLst>
-                                </p:cTn>
-                              </p:par>
-                            </p:childTnLst>
-                          </p:cTn>
-                        </p:par>
-                      </p:childTnLst>
-                    </p:cTn>
-                  </p:par>
-                </p:childTnLst>
-              </p:cTn>
-              <p:prevCondLst>
-                <p:cond evt="onPrev" delay="0">
-                  <p:tgtEl>
-                    <p:sldTgt/>
-                  </p:tgtEl>
-                </p:cond>
-              </p:prevCondLst>
-              <p:nextCondLst>
-                <p:cond evt="onNext" delay="0">
-                  <p:tgtEl>
-                    <p:sldTgt/>
-                  </p:tgtEl>
-                </p:cond>
-              </p:nextCondLst>
-            </p:seq>
-          </p:childTnLst>
-        </p:cTn>
-      </p:par>
-    </p:tnLst>
-    <p:bldLst>
-      <p:bldP spid="62" grpId="0"/>
-    </p:bldLst>
-  </p:timing>
 </p:sld>
 </file>
 

</xml_diff>